<commit_message>
docs(ppt): fill title, abstract, intro, lit survey, problem, methodology in trimmed synopsis
</commit_message>
<xml_diff>
--- a/ppt/PROJECT SYNOPSIS PPT-FORMAT_TRIMMED.pptx
+++ b/ppt/PROJECT SYNOPSIS PPT-FORMAT_TRIMMED.pptx
@@ -2112,21 +2112,21 @@
                 <a:latin typeface="Times New Roman"/>
                 <a:cs typeface="Times New Roman"/>
               </a:rPr>
-              <a:t>PROJECT</a:t>
+              <a:t>SynCura: Predictive ICU Monitoring System Using Attention-Based LSTM</a:t>
             </a:r>
             <a:r>
               <a:rPr sz="6000" spc="-95" dirty="0">
                 <a:latin typeface="Times New Roman"/>
                 <a:cs typeface="Times New Roman"/>
               </a:rPr>
-              <a:t> </a:t>
+              <a:t/>
             </a:r>
             <a:r>
               <a:rPr sz="6000" spc="-10" dirty="0">
                 <a:latin typeface="Times New Roman"/>
                 <a:cs typeface="Times New Roman"/>
               </a:rPr>
-              <a:t>TITLE</a:t>
+              <a:t/>
             </a:r>
             <a:endParaRPr lang="en-IN" sz="6000" spc="-10" dirty="0">
               <a:latin typeface="Times New Roman"/>
@@ -2139,6 +2139,12 @@
                 <a:spcPts val="100"/>
               </a:spcBef>
             </a:pPr>
+            <a:r>
+              <a:rPr sz="1800">
+                <a:latin typeface="Times New Roman"/>
+              </a:rPr>
+              <a:t>Real-time in-hospital mortality risk with SHAP + temporal-attention explainability</a:t>
+            </a:r>
             <a:endParaRPr lang="en-IN" spc="-20" dirty="0">
               <a:latin typeface="Times New Roman"/>
               <a:cs typeface="Times New Roman"/>
@@ -2187,53 +2193,53 @@
               </a:spcBef>
             </a:pPr>
             <a:r>
-              <a:rPr lang="en-US" sz="1800" dirty="0">
-                <a:latin typeface="Times New Roman"/>
-                <a:cs typeface="Times New Roman"/>
-              </a:rPr>
-              <a:t>UNDER</a:t>
-            </a:r>
-            <a:r>
-              <a:rPr lang="en-US" sz="1800" spc="-105" dirty="0">
-                <a:latin typeface="Times New Roman"/>
-                <a:cs typeface="Times New Roman"/>
-              </a:rPr>
-              <a:t> </a:t>
-            </a:r>
-            <a:r>
-              <a:rPr lang="en-US" sz="1800" dirty="0">
-                <a:latin typeface="Times New Roman"/>
-                <a:cs typeface="Times New Roman"/>
-              </a:rPr>
-              <a:t>THE</a:t>
-            </a:r>
-            <a:r>
-              <a:rPr lang="en-US" sz="1800" spc="-75" dirty="0">
-                <a:latin typeface="Times New Roman"/>
-                <a:cs typeface="Times New Roman"/>
-              </a:rPr>
-              <a:t> </a:t>
-            </a:r>
-            <a:r>
-              <a:rPr lang="en-US" sz="1800" dirty="0">
-                <a:latin typeface="Times New Roman"/>
-                <a:cs typeface="Times New Roman"/>
-              </a:rPr>
-              <a:t>GUIDANCE</a:t>
-            </a:r>
-            <a:r>
-              <a:rPr lang="en-US" sz="1800" spc="-60" dirty="0">
-                <a:latin typeface="Times New Roman"/>
-                <a:cs typeface="Times New Roman"/>
-              </a:rPr>
-              <a:t> </a:t>
-            </a:r>
-            <a:r>
-              <a:rPr lang="en-US" sz="1800" spc="-25" dirty="0">
-                <a:latin typeface="Times New Roman"/>
-                <a:cs typeface="Times New Roman"/>
-              </a:rPr>
-              <a:t>OF					TEAM MEMBERS </a:t>
+              <a:rPr lang="en-US" sz="1400" dirty="0">
+                <a:latin typeface="Times New Roman"/>
+                <a:cs typeface="Times New Roman"/>
+              </a:rPr>
+              <a:t>UNDER THE GUIDANCE OF                    TEAM MEMBERS</a:t>
+            </a:r>
+            <a:r>
+              <a:rPr lang="en-US" sz="1400" spc="-105" dirty="0">
+                <a:latin typeface="Times New Roman"/>
+                <a:cs typeface="Times New Roman"/>
+              </a:rPr>
+              <a:t/>
+            </a:r>
+            <a:r>
+              <a:rPr lang="en-US" sz="1400" dirty="0">
+                <a:latin typeface="Times New Roman"/>
+                <a:cs typeface="Times New Roman"/>
+              </a:rPr>
+              <a:t/>
+            </a:r>
+            <a:r>
+              <a:rPr lang="en-US" sz="1400" spc="-75" dirty="0">
+                <a:latin typeface="Times New Roman"/>
+                <a:cs typeface="Times New Roman"/>
+              </a:rPr>
+              <a:t/>
+            </a:r>
+            <a:r>
+              <a:rPr lang="en-US" sz="1400" dirty="0">
+                <a:latin typeface="Times New Roman"/>
+                <a:cs typeface="Times New Roman"/>
+              </a:rPr>
+              <a:t/>
+            </a:r>
+            <a:r>
+              <a:rPr lang="en-US" sz="1400" spc="-60" dirty="0">
+                <a:latin typeface="Times New Roman"/>
+                <a:cs typeface="Times New Roman"/>
+              </a:rPr>
+              <a:t/>
+            </a:r>
+            <a:r>
+              <a:rPr lang="en-US" sz="1400" spc="-25" dirty="0">
+                <a:latin typeface="Times New Roman"/>
+                <a:cs typeface="Times New Roman"/>
+              </a:rPr>
+              <a:t/>
             </a:r>
             <a:endParaRPr lang="en-US" sz="1800" dirty="0">
               <a:latin typeface="Times New Roman"/>
@@ -2250,25 +2256,25 @@
               </a:spcBef>
             </a:pPr>
             <a:r>
-              <a:rPr lang="en-US" sz="1800" spc="-10" dirty="0">
-                <a:latin typeface="Times New Roman"/>
-                <a:cs typeface="Times New Roman"/>
-              </a:rPr>
-              <a:t>GUIDE</a:t>
-            </a:r>
-            <a:r>
-              <a:rPr lang="en-US" sz="1800" spc="-75" dirty="0">
-                <a:latin typeface="Times New Roman"/>
-                <a:cs typeface="Times New Roman"/>
-              </a:rPr>
-              <a:t> </a:t>
-            </a:r>
-            <a:r>
-              <a:rPr lang="en-US" sz="1800" spc="-20" dirty="0">
-                <a:latin typeface="Times New Roman"/>
-                <a:cs typeface="Times New Roman"/>
-              </a:rPr>
-              <a:t>NAME					NAME &amp; USN (ASCENDING ORDER)</a:t>
+              <a:rPr lang="en-US" sz="1400" spc="-10" dirty="0">
+                <a:latin typeface="Times New Roman"/>
+                <a:cs typeface="Times New Roman"/>
+              </a:rPr>
+              <a:t>Guide Name (TBD)                    Abdul Ahad Ikkeri - 4PA24CS002, Fathima Reeha - 4PA24CS026, Fizan Feroz - 4PA24CS032</a:t>
+            </a:r>
+            <a:r>
+              <a:rPr lang="en-US" sz="1400" spc="-75" dirty="0">
+                <a:latin typeface="Times New Roman"/>
+                <a:cs typeface="Times New Roman"/>
+              </a:rPr>
+              <a:t/>
+            </a:r>
+            <a:r>
+              <a:rPr lang="en-US" sz="1400" spc="-20" dirty="0">
+                <a:latin typeface="Times New Roman"/>
+                <a:cs typeface="Times New Roman"/>
+              </a:rPr>
+              <a:t/>
             </a:r>
           </a:p>
           <a:p>
@@ -2281,11 +2287,11 @@
               </a:spcBef>
             </a:pPr>
             <a:r>
-              <a:rPr lang="en-US" spc="-20" dirty="0">
-                <a:latin typeface="Times New Roman"/>
-                <a:cs typeface="Times New Roman"/>
-              </a:rPr>
-              <a:t>DESIGNATION</a:t>
+              <a:rPr lang="en-US" spc="-20" dirty="0" sz="1400">
+                <a:latin typeface="Times New Roman"/>
+                <a:cs typeface="Times New Roman"/>
+              </a:rPr>
+              <a:t>Designation (TBD)</a:t>
             </a:r>
             <a:endParaRPr lang="en-US" sz="1800" dirty="0">
               <a:latin typeface="Times New Roman"/>
@@ -2911,529 +2917,69 @@
             </a:endParaRPr>
           </a:p>
           <a:p>
-            <a:pPr marL="240029" indent="-227329">
-              <a:lnSpc>
-                <a:spcPct val="100000"/>
-              </a:lnSpc>
-              <a:spcBef>
-                <a:spcPts val="2650"/>
-              </a:spcBef>
-              <a:buFont typeface="Arial MT"/>
-              <a:buChar char="•"/>
-              <a:tabLst>
-                <a:tab pos="240029" algn="l"/>
-              </a:tabLst>
-            </a:pPr>
-            <a:r>
-              <a:rPr sz="2800" dirty="0">
-                <a:solidFill>
-                  <a:srgbClr val="2D5395"/>
-                </a:solidFill>
-                <a:latin typeface="Times New Roman"/>
-                <a:cs typeface="Times New Roman"/>
-              </a:rPr>
-              <a:t>Content</a:t>
-            </a:r>
-            <a:r>
-              <a:rPr sz="2800" spc="-50" dirty="0">
-                <a:solidFill>
-                  <a:srgbClr val="2D5395"/>
-                </a:solidFill>
-                <a:latin typeface="Times New Roman"/>
-                <a:cs typeface="Times New Roman"/>
-              </a:rPr>
-              <a:t> </a:t>
-            </a:r>
-            <a:r>
-              <a:rPr sz="2800" dirty="0">
-                <a:solidFill>
-                  <a:srgbClr val="2D5395"/>
-                </a:solidFill>
-                <a:latin typeface="Times New Roman"/>
-                <a:cs typeface="Times New Roman"/>
-              </a:rPr>
-              <a:t>should</a:t>
-            </a:r>
-            <a:r>
-              <a:rPr sz="2800" spc="-60" dirty="0">
-                <a:solidFill>
-                  <a:srgbClr val="2D5395"/>
-                </a:solidFill>
-                <a:latin typeface="Times New Roman"/>
-                <a:cs typeface="Times New Roman"/>
-              </a:rPr>
-              <a:t> </a:t>
-            </a:r>
-            <a:r>
-              <a:rPr sz="2800" dirty="0">
-                <a:solidFill>
-                  <a:srgbClr val="2D5395"/>
-                </a:solidFill>
-                <a:latin typeface="Times New Roman"/>
-                <a:cs typeface="Times New Roman"/>
-              </a:rPr>
-              <a:t>be</a:t>
-            </a:r>
-            <a:r>
-              <a:rPr sz="2800" spc="-50" dirty="0">
-                <a:solidFill>
-                  <a:srgbClr val="2D5395"/>
-                </a:solidFill>
-                <a:latin typeface="Times New Roman"/>
-                <a:cs typeface="Times New Roman"/>
-              </a:rPr>
-              <a:t> </a:t>
-            </a:r>
-            <a:r>
-              <a:rPr sz="2800" dirty="0">
-                <a:solidFill>
-                  <a:srgbClr val="2D5395"/>
-                </a:solidFill>
-                <a:latin typeface="Times New Roman"/>
-                <a:cs typeface="Times New Roman"/>
-              </a:rPr>
-              <a:t>pointwise</a:t>
-            </a:r>
-            <a:r>
-              <a:rPr sz="2800" spc="-60" dirty="0">
-                <a:solidFill>
-                  <a:srgbClr val="2D5395"/>
-                </a:solidFill>
-                <a:latin typeface="Times New Roman"/>
-                <a:cs typeface="Times New Roman"/>
-              </a:rPr>
-              <a:t> </a:t>
-            </a:r>
-            <a:r>
-              <a:rPr sz="2800" dirty="0">
-                <a:solidFill>
-                  <a:srgbClr val="2D5395"/>
-                </a:solidFill>
-                <a:latin typeface="Times New Roman"/>
-                <a:cs typeface="Times New Roman"/>
-              </a:rPr>
-              <a:t>and</a:t>
-            </a:r>
-            <a:r>
-              <a:rPr sz="2800" spc="-25" dirty="0">
-                <a:solidFill>
-                  <a:srgbClr val="2D5395"/>
-                </a:solidFill>
-                <a:latin typeface="Times New Roman"/>
-                <a:cs typeface="Times New Roman"/>
-              </a:rPr>
-              <a:t> </a:t>
-            </a:r>
-            <a:r>
-              <a:rPr sz="2800" spc="-10" dirty="0">
-                <a:solidFill>
-                  <a:srgbClr val="2D5395"/>
-                </a:solidFill>
-                <a:latin typeface="Times New Roman"/>
-                <a:cs typeface="Times New Roman"/>
-              </a:rPr>
-              <a:t>justified.</a:t>
-            </a:r>
-            <a:endParaRPr sz="2800" dirty="0">
-              <a:latin typeface="Times New Roman"/>
-              <a:cs typeface="Times New Roman"/>
-            </a:endParaRPr>
-          </a:p>
-          <a:p>
-            <a:pPr marL="240029" indent="-227329">
-              <a:lnSpc>
-                <a:spcPct val="100000"/>
-              </a:lnSpc>
-              <a:spcBef>
-                <a:spcPts val="2005"/>
-              </a:spcBef>
-              <a:buFont typeface="Arial MT"/>
-              <a:buChar char="•"/>
-              <a:tabLst>
-                <a:tab pos="240029" algn="l"/>
-              </a:tabLst>
-            </a:pPr>
-            <a:r>
-              <a:rPr sz="2800" dirty="0">
-                <a:solidFill>
-                  <a:srgbClr val="2D5395"/>
-                </a:solidFill>
-                <a:latin typeface="Times New Roman"/>
-                <a:cs typeface="Times New Roman"/>
-              </a:rPr>
-              <a:t>Bullets</a:t>
-            </a:r>
-            <a:r>
-              <a:rPr sz="2800" spc="-65" dirty="0">
-                <a:solidFill>
-                  <a:srgbClr val="2D5395"/>
-                </a:solidFill>
-                <a:latin typeface="Times New Roman"/>
-                <a:cs typeface="Times New Roman"/>
-              </a:rPr>
-              <a:t> </a:t>
-            </a:r>
-            <a:r>
-              <a:rPr sz="2800" dirty="0">
-                <a:solidFill>
-                  <a:srgbClr val="2D5395"/>
-                </a:solidFill>
-                <a:latin typeface="Times New Roman"/>
-                <a:cs typeface="Times New Roman"/>
-              </a:rPr>
-              <a:t>should</a:t>
-            </a:r>
-            <a:r>
-              <a:rPr sz="2800" spc="-80" dirty="0">
-                <a:solidFill>
-                  <a:srgbClr val="2D5395"/>
-                </a:solidFill>
-                <a:latin typeface="Times New Roman"/>
-                <a:cs typeface="Times New Roman"/>
-              </a:rPr>
-              <a:t> </a:t>
-            </a:r>
-            <a:r>
-              <a:rPr sz="2800" dirty="0">
-                <a:solidFill>
-                  <a:srgbClr val="2D5395"/>
-                </a:solidFill>
-                <a:latin typeface="Times New Roman"/>
-                <a:cs typeface="Times New Roman"/>
-              </a:rPr>
-              <a:t>be</a:t>
-            </a:r>
-            <a:r>
-              <a:rPr sz="2800" spc="-65" dirty="0">
-                <a:solidFill>
-                  <a:srgbClr val="2D5395"/>
-                </a:solidFill>
-                <a:latin typeface="Times New Roman"/>
-                <a:cs typeface="Times New Roman"/>
-              </a:rPr>
-              <a:t> </a:t>
-            </a:r>
-            <a:r>
-              <a:rPr sz="2800" dirty="0">
-                <a:solidFill>
-                  <a:srgbClr val="2D5395"/>
-                </a:solidFill>
-                <a:latin typeface="Times New Roman"/>
-                <a:cs typeface="Times New Roman"/>
-              </a:rPr>
-              <a:t>same</a:t>
-            </a:r>
-            <a:r>
-              <a:rPr sz="2800" spc="-20" dirty="0">
-                <a:solidFill>
-                  <a:srgbClr val="2D5395"/>
-                </a:solidFill>
-                <a:latin typeface="Times New Roman"/>
-                <a:cs typeface="Times New Roman"/>
-              </a:rPr>
-              <a:t> </a:t>
-            </a:r>
-            <a:r>
-              <a:rPr sz="2800" spc="-10" dirty="0">
-                <a:solidFill>
-                  <a:srgbClr val="2D5395"/>
-                </a:solidFill>
-                <a:latin typeface="Times New Roman"/>
-                <a:cs typeface="Times New Roman"/>
-              </a:rPr>
-              <a:t>throughout.</a:t>
-            </a:r>
-            <a:endParaRPr sz="2800" dirty="0">
-              <a:latin typeface="Times New Roman"/>
-              <a:cs typeface="Times New Roman"/>
-            </a:endParaRPr>
-          </a:p>
-          <a:p>
-            <a:pPr marL="240029" indent="-227329">
-              <a:lnSpc>
-                <a:spcPct val="100000"/>
-              </a:lnSpc>
-              <a:spcBef>
-                <a:spcPts val="2005"/>
-              </a:spcBef>
-              <a:buFont typeface="Arial MT"/>
-              <a:buChar char="•"/>
-              <a:tabLst>
-                <a:tab pos="240029" algn="l"/>
-              </a:tabLst>
-            </a:pPr>
-            <a:r>
-              <a:rPr sz="2800" dirty="0">
-                <a:solidFill>
-                  <a:srgbClr val="2D5395"/>
-                </a:solidFill>
-                <a:latin typeface="Times New Roman"/>
-                <a:cs typeface="Times New Roman"/>
-              </a:rPr>
-              <a:t>Font</a:t>
-            </a:r>
-            <a:r>
-              <a:rPr sz="2800" spc="-114" dirty="0">
-                <a:solidFill>
-                  <a:srgbClr val="2D5395"/>
-                </a:solidFill>
-                <a:latin typeface="Times New Roman"/>
-                <a:cs typeface="Times New Roman"/>
-              </a:rPr>
-              <a:t> </a:t>
-            </a:r>
-            <a:r>
-              <a:rPr sz="2800" dirty="0">
-                <a:solidFill>
-                  <a:srgbClr val="2D5395"/>
-                </a:solidFill>
-                <a:latin typeface="Times New Roman"/>
-                <a:cs typeface="Times New Roman"/>
-              </a:rPr>
-              <a:t>must</a:t>
-            </a:r>
-            <a:r>
-              <a:rPr sz="2800" spc="-75" dirty="0">
-                <a:solidFill>
-                  <a:srgbClr val="2D5395"/>
-                </a:solidFill>
-                <a:latin typeface="Times New Roman"/>
-                <a:cs typeface="Times New Roman"/>
-              </a:rPr>
-              <a:t> </a:t>
-            </a:r>
-            <a:r>
-              <a:rPr sz="2800" dirty="0">
-                <a:solidFill>
-                  <a:srgbClr val="2D5395"/>
-                </a:solidFill>
-                <a:latin typeface="Times New Roman"/>
-                <a:cs typeface="Times New Roman"/>
-              </a:rPr>
-              <a:t>be</a:t>
-            </a:r>
-            <a:r>
-              <a:rPr sz="2800" spc="-150" dirty="0">
-                <a:solidFill>
-                  <a:srgbClr val="2D5395"/>
-                </a:solidFill>
-                <a:latin typeface="Times New Roman"/>
-                <a:cs typeface="Times New Roman"/>
-              </a:rPr>
-              <a:t> </a:t>
-            </a:r>
-            <a:r>
-              <a:rPr sz="2800" dirty="0">
-                <a:solidFill>
-                  <a:srgbClr val="2D5395"/>
-                </a:solidFill>
-                <a:latin typeface="Times New Roman"/>
-                <a:cs typeface="Times New Roman"/>
-              </a:rPr>
-              <a:t>Times</a:t>
-            </a:r>
-            <a:r>
-              <a:rPr sz="2800" spc="-70" dirty="0">
-                <a:solidFill>
-                  <a:srgbClr val="2D5395"/>
-                </a:solidFill>
-                <a:latin typeface="Times New Roman"/>
-                <a:cs typeface="Times New Roman"/>
-              </a:rPr>
-              <a:t> </a:t>
-            </a:r>
-            <a:r>
-              <a:rPr sz="2800" dirty="0">
-                <a:solidFill>
-                  <a:srgbClr val="2D5395"/>
-                </a:solidFill>
-                <a:latin typeface="Times New Roman"/>
-                <a:cs typeface="Times New Roman"/>
-              </a:rPr>
-              <a:t>New</a:t>
-            </a:r>
-            <a:r>
-              <a:rPr sz="2800" spc="-80" dirty="0">
-                <a:solidFill>
-                  <a:srgbClr val="2D5395"/>
-                </a:solidFill>
-                <a:latin typeface="Times New Roman"/>
-                <a:cs typeface="Times New Roman"/>
-              </a:rPr>
-              <a:t> </a:t>
-            </a:r>
-            <a:r>
-              <a:rPr sz="2800" spc="-10" dirty="0">
-                <a:solidFill>
-                  <a:srgbClr val="2D5395"/>
-                </a:solidFill>
-                <a:latin typeface="Times New Roman"/>
-                <a:cs typeface="Times New Roman"/>
-              </a:rPr>
-              <a:t>Roman.</a:t>
-            </a:r>
-            <a:endParaRPr sz="2800" dirty="0">
-              <a:latin typeface="Times New Roman"/>
-              <a:cs typeface="Times New Roman"/>
-            </a:endParaRPr>
-          </a:p>
-          <a:p>
-            <a:pPr marL="240029" indent="-227329">
-              <a:lnSpc>
-                <a:spcPct val="100000"/>
-              </a:lnSpc>
-              <a:spcBef>
-                <a:spcPts val="1995"/>
-              </a:spcBef>
-              <a:buFont typeface="Arial MT"/>
-              <a:buChar char="•"/>
-              <a:tabLst>
-                <a:tab pos="240029" algn="l"/>
-              </a:tabLst>
-            </a:pPr>
-            <a:r>
-              <a:rPr sz="2800" dirty="0">
-                <a:solidFill>
-                  <a:srgbClr val="2D5395"/>
-                </a:solidFill>
-                <a:latin typeface="Times New Roman"/>
-                <a:cs typeface="Times New Roman"/>
-              </a:rPr>
-              <a:t>Line</a:t>
-            </a:r>
-            <a:r>
-              <a:rPr sz="2800" spc="-125" dirty="0">
-                <a:solidFill>
-                  <a:srgbClr val="2D5395"/>
-                </a:solidFill>
-                <a:latin typeface="Times New Roman"/>
-                <a:cs typeface="Times New Roman"/>
-              </a:rPr>
-              <a:t> </a:t>
-            </a:r>
-            <a:r>
-              <a:rPr sz="2800" dirty="0">
-                <a:solidFill>
-                  <a:srgbClr val="2D5395"/>
-                </a:solidFill>
-                <a:latin typeface="Times New Roman"/>
-                <a:cs typeface="Times New Roman"/>
-              </a:rPr>
-              <a:t>spacing</a:t>
-            </a:r>
-            <a:r>
-              <a:rPr sz="2800" spc="-135" dirty="0">
-                <a:solidFill>
-                  <a:srgbClr val="2D5395"/>
-                </a:solidFill>
-                <a:latin typeface="Times New Roman"/>
-                <a:cs typeface="Times New Roman"/>
-              </a:rPr>
-              <a:t> </a:t>
-            </a:r>
-            <a:r>
-              <a:rPr sz="2800" spc="-25" dirty="0">
-                <a:solidFill>
-                  <a:srgbClr val="2D5395"/>
-                </a:solidFill>
-                <a:latin typeface="Times New Roman"/>
-                <a:cs typeface="Times New Roman"/>
-              </a:rPr>
-              <a:t>1.5</a:t>
-            </a:r>
-            <a:endParaRPr sz="2800" dirty="0">
-              <a:latin typeface="Times New Roman"/>
-              <a:cs typeface="Times New Roman"/>
-            </a:endParaRPr>
-          </a:p>
-          <a:p>
-            <a:pPr marL="240029" indent="-227329">
-              <a:lnSpc>
-                <a:spcPct val="100000"/>
-              </a:lnSpc>
-              <a:spcBef>
-                <a:spcPts val="2005"/>
-              </a:spcBef>
-              <a:buFont typeface="Arial MT"/>
-              <a:buChar char="•"/>
-              <a:tabLst>
-                <a:tab pos="240029" algn="l"/>
-              </a:tabLst>
-            </a:pPr>
-            <a:r>
-              <a:rPr sz="2800" dirty="0">
-                <a:solidFill>
-                  <a:srgbClr val="2D5395"/>
-                </a:solidFill>
-                <a:latin typeface="Times New Roman"/>
-                <a:cs typeface="Times New Roman"/>
-              </a:rPr>
-              <a:t>Background</a:t>
-            </a:r>
-            <a:r>
-              <a:rPr sz="2800" spc="-90" dirty="0">
-                <a:solidFill>
-                  <a:srgbClr val="2D5395"/>
-                </a:solidFill>
-                <a:latin typeface="Times New Roman"/>
-                <a:cs typeface="Times New Roman"/>
-              </a:rPr>
-              <a:t> </a:t>
-            </a:r>
-            <a:r>
-              <a:rPr sz="2800" dirty="0">
-                <a:solidFill>
-                  <a:srgbClr val="2D5395"/>
-                </a:solidFill>
-                <a:latin typeface="Times New Roman"/>
-                <a:cs typeface="Times New Roman"/>
-              </a:rPr>
-              <a:t>must</a:t>
-            </a:r>
-            <a:r>
-              <a:rPr sz="2800" spc="-95" dirty="0">
-                <a:solidFill>
-                  <a:srgbClr val="2D5395"/>
-                </a:solidFill>
-                <a:latin typeface="Times New Roman"/>
-                <a:cs typeface="Times New Roman"/>
-              </a:rPr>
-              <a:t> </a:t>
-            </a:r>
-            <a:r>
-              <a:rPr sz="2800" dirty="0">
-                <a:solidFill>
-                  <a:srgbClr val="2D5395"/>
-                </a:solidFill>
-                <a:latin typeface="Times New Roman"/>
-                <a:cs typeface="Times New Roman"/>
-              </a:rPr>
-              <a:t>be</a:t>
-            </a:r>
-            <a:r>
-              <a:rPr sz="2800" spc="-100" dirty="0">
-                <a:solidFill>
-                  <a:srgbClr val="2D5395"/>
-                </a:solidFill>
-                <a:latin typeface="Times New Roman"/>
-                <a:cs typeface="Times New Roman"/>
-              </a:rPr>
-              <a:t> </a:t>
-            </a:r>
-            <a:r>
-              <a:rPr sz="2800" spc="-10" dirty="0">
-                <a:solidFill>
-                  <a:srgbClr val="2D5395"/>
-                </a:solidFill>
-                <a:latin typeface="Times New Roman"/>
-                <a:cs typeface="Times New Roman"/>
-              </a:rPr>
-              <a:t>white.</a:t>
-            </a:r>
-            <a:endParaRPr sz="2800" dirty="0">
-              <a:latin typeface="Times New Roman"/>
-              <a:cs typeface="Times New Roman"/>
-            </a:endParaRPr>
+            <a:pPr algn="just">
+              <a:lnSpc>
+                <a:spcPct val="150000"/>
+              </a:lnSpc>
+            </a:pPr>
+            <a:r>
+              <a:rPr sz="1800">
+                <a:latin typeface="Times New Roman"/>
+              </a:rPr>
+              <a:t>ICU deterioration is a leading cause of preventable in-hospital mortality; static scores like NEWS2 miss temporal trends.</a:t>
+            </a:r>
+          </a:p>
+          <a:p>
+            <a:pPr algn="just">
+              <a:lnSpc>
+                <a:spcPct val="150000"/>
+              </a:lnSpc>
+            </a:pPr>
+            <a:r>
+              <a:rPr sz="1800">
+                <a:latin typeface="Times New Roman"/>
+              </a:rPr>
+              <a:t>SynCura uses an attention-based LSTM on 12 features x 90-minute windows with FastAPI backend and React dashboard.</a:t>
+            </a:r>
+          </a:p>
+          <a:p>
+            <a:pPr algn="just">
+              <a:lnSpc>
+                <a:spcPct val="150000"/>
+              </a:lnSpc>
+            </a:pPr>
+            <a:r>
+              <a:rPr sz="1800">
+                <a:latin typeface="Times New Roman"/>
+              </a:rPr>
+              <a:t>Trained and evaluated on PhysioNet 2012 Challenge data with in-hospital mortality labels (4,000 stays).</a:t>
+            </a:r>
+          </a:p>
+          <a:p>
+            <a:pPr algn="just">
+              <a:lnSpc>
+                <a:spcPct val="150000"/>
+              </a:lnSpc>
+            </a:pPr>
+            <a:r>
+              <a:rPr sz="1800">
+                <a:latin typeface="Times New Roman"/>
+              </a:rPr>
+              <a:t>Deployed 3-model ensemble (e12+e13+c53): validation AUC 0.840, fresh unseen holdout AUC 0.834.</a:t>
+            </a:r>
+          </a:p>
+          <a:p>
+            <a:pPr algn="just">
+              <a:lnSpc>
+                <a:spcPct val="150000"/>
+              </a:lnSpc>
+            </a:pPr>
+            <a:r>
+              <a:rPr sz="1800">
+                <a:latin typeface="Times New Roman"/>
+              </a:rPr>
+              <a:t>Provides real-time risk scoring with SHAP and attention explainability; research prototype, not a medical device.</a:t>
+            </a:r>
           </a:p>
         </p:txBody>
       </p:sp>
@@ -3829,529 +3375,69 @@
             </a:endParaRPr>
           </a:p>
           <a:p>
-            <a:pPr marL="240029" indent="-227329">
-              <a:lnSpc>
-                <a:spcPct val="100000"/>
-              </a:lnSpc>
-              <a:spcBef>
-                <a:spcPts val="3045"/>
-              </a:spcBef>
-              <a:buFont typeface="Arial MT"/>
-              <a:buChar char="•"/>
-              <a:tabLst>
-                <a:tab pos="240029" algn="l"/>
-              </a:tabLst>
-            </a:pPr>
-            <a:r>
-              <a:rPr sz="2800" dirty="0">
-                <a:solidFill>
-                  <a:srgbClr val="2D5395"/>
-                </a:solidFill>
-                <a:latin typeface="Times New Roman"/>
-                <a:cs typeface="Times New Roman"/>
-              </a:rPr>
-              <a:t>Content</a:t>
-            </a:r>
-            <a:r>
-              <a:rPr sz="2800" spc="-85" dirty="0">
-                <a:solidFill>
-                  <a:srgbClr val="2D5395"/>
-                </a:solidFill>
-                <a:latin typeface="Times New Roman"/>
-                <a:cs typeface="Times New Roman"/>
-              </a:rPr>
-              <a:t> </a:t>
-            </a:r>
-            <a:r>
-              <a:rPr sz="2800" dirty="0">
-                <a:solidFill>
-                  <a:srgbClr val="2D5395"/>
-                </a:solidFill>
-                <a:latin typeface="Times New Roman"/>
-                <a:cs typeface="Times New Roman"/>
-              </a:rPr>
-              <a:t>should</a:t>
-            </a:r>
-            <a:r>
-              <a:rPr sz="2800" spc="-85" dirty="0">
-                <a:solidFill>
-                  <a:srgbClr val="2D5395"/>
-                </a:solidFill>
-                <a:latin typeface="Times New Roman"/>
-                <a:cs typeface="Times New Roman"/>
-              </a:rPr>
-              <a:t> </a:t>
-            </a:r>
-            <a:r>
-              <a:rPr sz="2800" dirty="0">
-                <a:solidFill>
-                  <a:srgbClr val="2D5395"/>
-                </a:solidFill>
-                <a:latin typeface="Times New Roman"/>
-                <a:cs typeface="Times New Roman"/>
-              </a:rPr>
-              <a:t>be</a:t>
-            </a:r>
-            <a:r>
-              <a:rPr sz="2800" spc="-70" dirty="0">
-                <a:solidFill>
-                  <a:srgbClr val="2D5395"/>
-                </a:solidFill>
-                <a:latin typeface="Times New Roman"/>
-                <a:cs typeface="Times New Roman"/>
-              </a:rPr>
-              <a:t> </a:t>
-            </a:r>
-            <a:r>
-              <a:rPr sz="2800" dirty="0">
-                <a:solidFill>
-                  <a:srgbClr val="2D5395"/>
-                </a:solidFill>
-                <a:latin typeface="Times New Roman"/>
-                <a:cs typeface="Times New Roman"/>
-              </a:rPr>
-              <a:t>pointwise</a:t>
-            </a:r>
-            <a:r>
-              <a:rPr sz="2800" spc="-80" dirty="0">
-                <a:solidFill>
-                  <a:srgbClr val="2D5395"/>
-                </a:solidFill>
-                <a:latin typeface="Times New Roman"/>
-                <a:cs typeface="Times New Roman"/>
-              </a:rPr>
-              <a:t> </a:t>
-            </a:r>
-            <a:r>
-              <a:rPr sz="2800" dirty="0">
-                <a:solidFill>
-                  <a:srgbClr val="2D5395"/>
-                </a:solidFill>
-                <a:latin typeface="Times New Roman"/>
-                <a:cs typeface="Times New Roman"/>
-              </a:rPr>
-              <a:t>and</a:t>
-            </a:r>
-            <a:r>
-              <a:rPr sz="2800" spc="-50" dirty="0">
-                <a:solidFill>
-                  <a:srgbClr val="2D5395"/>
-                </a:solidFill>
-                <a:latin typeface="Times New Roman"/>
-                <a:cs typeface="Times New Roman"/>
-              </a:rPr>
-              <a:t> </a:t>
-            </a:r>
-            <a:r>
-              <a:rPr sz="2800" spc="-10" dirty="0">
-                <a:solidFill>
-                  <a:srgbClr val="2D5395"/>
-                </a:solidFill>
-                <a:latin typeface="Times New Roman"/>
-                <a:cs typeface="Times New Roman"/>
-              </a:rPr>
-              <a:t>justified.</a:t>
-            </a:r>
-            <a:endParaRPr sz="2800" dirty="0">
-              <a:latin typeface="Times New Roman"/>
-              <a:cs typeface="Times New Roman"/>
-            </a:endParaRPr>
-          </a:p>
-          <a:p>
-            <a:pPr marL="240029" indent="-227329">
-              <a:lnSpc>
-                <a:spcPct val="100000"/>
-              </a:lnSpc>
-              <a:spcBef>
-                <a:spcPts val="2005"/>
-              </a:spcBef>
-              <a:buFont typeface="Arial MT"/>
-              <a:buChar char="•"/>
-              <a:tabLst>
-                <a:tab pos="240029" algn="l"/>
-              </a:tabLst>
-            </a:pPr>
-            <a:r>
-              <a:rPr sz="2800" dirty="0">
-                <a:solidFill>
-                  <a:srgbClr val="2D5395"/>
-                </a:solidFill>
-                <a:latin typeface="Times New Roman"/>
-                <a:cs typeface="Times New Roman"/>
-              </a:rPr>
-              <a:t>Bullets</a:t>
-            </a:r>
-            <a:r>
-              <a:rPr sz="2800" spc="-65" dirty="0">
-                <a:solidFill>
-                  <a:srgbClr val="2D5395"/>
-                </a:solidFill>
-                <a:latin typeface="Times New Roman"/>
-                <a:cs typeface="Times New Roman"/>
-              </a:rPr>
-              <a:t> </a:t>
-            </a:r>
-            <a:r>
-              <a:rPr sz="2800" dirty="0">
-                <a:solidFill>
-                  <a:srgbClr val="2D5395"/>
-                </a:solidFill>
-                <a:latin typeface="Times New Roman"/>
-                <a:cs typeface="Times New Roman"/>
-              </a:rPr>
-              <a:t>should</a:t>
-            </a:r>
-            <a:r>
-              <a:rPr sz="2800" spc="-80" dirty="0">
-                <a:solidFill>
-                  <a:srgbClr val="2D5395"/>
-                </a:solidFill>
-                <a:latin typeface="Times New Roman"/>
-                <a:cs typeface="Times New Roman"/>
-              </a:rPr>
-              <a:t> </a:t>
-            </a:r>
-            <a:r>
-              <a:rPr sz="2800" dirty="0">
-                <a:solidFill>
-                  <a:srgbClr val="2D5395"/>
-                </a:solidFill>
-                <a:latin typeface="Times New Roman"/>
-                <a:cs typeface="Times New Roman"/>
-              </a:rPr>
-              <a:t>be</a:t>
-            </a:r>
-            <a:r>
-              <a:rPr sz="2800" spc="-65" dirty="0">
-                <a:solidFill>
-                  <a:srgbClr val="2D5395"/>
-                </a:solidFill>
-                <a:latin typeface="Times New Roman"/>
-                <a:cs typeface="Times New Roman"/>
-              </a:rPr>
-              <a:t> </a:t>
-            </a:r>
-            <a:r>
-              <a:rPr sz="2800" dirty="0">
-                <a:solidFill>
-                  <a:srgbClr val="2D5395"/>
-                </a:solidFill>
-                <a:latin typeface="Times New Roman"/>
-                <a:cs typeface="Times New Roman"/>
-              </a:rPr>
-              <a:t>same</a:t>
-            </a:r>
-            <a:r>
-              <a:rPr sz="2800" spc="-20" dirty="0">
-                <a:solidFill>
-                  <a:srgbClr val="2D5395"/>
-                </a:solidFill>
-                <a:latin typeface="Times New Roman"/>
-                <a:cs typeface="Times New Roman"/>
-              </a:rPr>
-              <a:t> </a:t>
-            </a:r>
-            <a:r>
-              <a:rPr sz="2800" spc="-10" dirty="0">
-                <a:solidFill>
-                  <a:srgbClr val="2D5395"/>
-                </a:solidFill>
-                <a:latin typeface="Times New Roman"/>
-                <a:cs typeface="Times New Roman"/>
-              </a:rPr>
-              <a:t>throughout.</a:t>
-            </a:r>
-            <a:endParaRPr sz="2800" dirty="0">
-              <a:latin typeface="Times New Roman"/>
-              <a:cs typeface="Times New Roman"/>
-            </a:endParaRPr>
-          </a:p>
-          <a:p>
-            <a:pPr marL="240029" indent="-227329">
-              <a:lnSpc>
-                <a:spcPct val="100000"/>
-              </a:lnSpc>
-              <a:spcBef>
-                <a:spcPts val="2005"/>
-              </a:spcBef>
-              <a:buFont typeface="Arial MT"/>
-              <a:buChar char="•"/>
-              <a:tabLst>
-                <a:tab pos="240029" algn="l"/>
-              </a:tabLst>
-            </a:pPr>
-            <a:r>
-              <a:rPr sz="2800" dirty="0">
-                <a:solidFill>
-                  <a:srgbClr val="2D5395"/>
-                </a:solidFill>
-                <a:latin typeface="Times New Roman"/>
-                <a:cs typeface="Times New Roman"/>
-              </a:rPr>
-              <a:t>Font</a:t>
-            </a:r>
-            <a:r>
-              <a:rPr sz="2800" spc="-114" dirty="0">
-                <a:solidFill>
-                  <a:srgbClr val="2D5395"/>
-                </a:solidFill>
-                <a:latin typeface="Times New Roman"/>
-                <a:cs typeface="Times New Roman"/>
-              </a:rPr>
-              <a:t> </a:t>
-            </a:r>
-            <a:r>
-              <a:rPr sz="2800" dirty="0">
-                <a:solidFill>
-                  <a:srgbClr val="2D5395"/>
-                </a:solidFill>
-                <a:latin typeface="Times New Roman"/>
-                <a:cs typeface="Times New Roman"/>
-              </a:rPr>
-              <a:t>must</a:t>
-            </a:r>
-            <a:r>
-              <a:rPr sz="2800" spc="-75" dirty="0">
-                <a:solidFill>
-                  <a:srgbClr val="2D5395"/>
-                </a:solidFill>
-                <a:latin typeface="Times New Roman"/>
-                <a:cs typeface="Times New Roman"/>
-              </a:rPr>
-              <a:t> </a:t>
-            </a:r>
-            <a:r>
-              <a:rPr sz="2800" dirty="0">
-                <a:solidFill>
-                  <a:srgbClr val="2D5395"/>
-                </a:solidFill>
-                <a:latin typeface="Times New Roman"/>
-                <a:cs typeface="Times New Roman"/>
-              </a:rPr>
-              <a:t>be</a:t>
-            </a:r>
-            <a:r>
-              <a:rPr sz="2800" spc="-150" dirty="0">
-                <a:solidFill>
-                  <a:srgbClr val="2D5395"/>
-                </a:solidFill>
-                <a:latin typeface="Times New Roman"/>
-                <a:cs typeface="Times New Roman"/>
-              </a:rPr>
-              <a:t> </a:t>
-            </a:r>
-            <a:r>
-              <a:rPr sz="2800" dirty="0">
-                <a:solidFill>
-                  <a:srgbClr val="2D5395"/>
-                </a:solidFill>
-                <a:latin typeface="Times New Roman"/>
-                <a:cs typeface="Times New Roman"/>
-              </a:rPr>
-              <a:t>Times</a:t>
-            </a:r>
-            <a:r>
-              <a:rPr sz="2800" spc="-70" dirty="0">
-                <a:solidFill>
-                  <a:srgbClr val="2D5395"/>
-                </a:solidFill>
-                <a:latin typeface="Times New Roman"/>
-                <a:cs typeface="Times New Roman"/>
-              </a:rPr>
-              <a:t> </a:t>
-            </a:r>
-            <a:r>
-              <a:rPr sz="2800" dirty="0">
-                <a:solidFill>
-                  <a:srgbClr val="2D5395"/>
-                </a:solidFill>
-                <a:latin typeface="Times New Roman"/>
-                <a:cs typeface="Times New Roman"/>
-              </a:rPr>
-              <a:t>New</a:t>
-            </a:r>
-            <a:r>
-              <a:rPr sz="2800" spc="-80" dirty="0">
-                <a:solidFill>
-                  <a:srgbClr val="2D5395"/>
-                </a:solidFill>
-                <a:latin typeface="Times New Roman"/>
-                <a:cs typeface="Times New Roman"/>
-              </a:rPr>
-              <a:t> </a:t>
-            </a:r>
-            <a:r>
-              <a:rPr sz="2800" spc="-10" dirty="0">
-                <a:solidFill>
-                  <a:srgbClr val="2D5395"/>
-                </a:solidFill>
-                <a:latin typeface="Times New Roman"/>
-                <a:cs typeface="Times New Roman"/>
-              </a:rPr>
-              <a:t>Roman.</a:t>
-            </a:r>
-            <a:endParaRPr sz="2800" dirty="0">
-              <a:latin typeface="Times New Roman"/>
-              <a:cs typeface="Times New Roman"/>
-            </a:endParaRPr>
-          </a:p>
-          <a:p>
-            <a:pPr marL="240029" indent="-227329">
-              <a:lnSpc>
-                <a:spcPct val="100000"/>
-              </a:lnSpc>
-              <a:spcBef>
-                <a:spcPts val="1995"/>
-              </a:spcBef>
-              <a:buFont typeface="Arial MT"/>
-              <a:buChar char="•"/>
-              <a:tabLst>
-                <a:tab pos="240029" algn="l"/>
-              </a:tabLst>
-            </a:pPr>
-            <a:r>
-              <a:rPr sz="2800" dirty="0">
-                <a:solidFill>
-                  <a:srgbClr val="2D5395"/>
-                </a:solidFill>
-                <a:latin typeface="Times New Roman"/>
-                <a:cs typeface="Times New Roman"/>
-              </a:rPr>
-              <a:t>Line</a:t>
-            </a:r>
-            <a:r>
-              <a:rPr sz="2800" spc="-125" dirty="0">
-                <a:solidFill>
-                  <a:srgbClr val="2D5395"/>
-                </a:solidFill>
-                <a:latin typeface="Times New Roman"/>
-                <a:cs typeface="Times New Roman"/>
-              </a:rPr>
-              <a:t> </a:t>
-            </a:r>
-            <a:r>
-              <a:rPr sz="2800" dirty="0">
-                <a:solidFill>
-                  <a:srgbClr val="2D5395"/>
-                </a:solidFill>
-                <a:latin typeface="Times New Roman"/>
-                <a:cs typeface="Times New Roman"/>
-              </a:rPr>
-              <a:t>spacing</a:t>
-            </a:r>
-            <a:r>
-              <a:rPr sz="2800" spc="-135" dirty="0">
-                <a:solidFill>
-                  <a:srgbClr val="2D5395"/>
-                </a:solidFill>
-                <a:latin typeface="Times New Roman"/>
-                <a:cs typeface="Times New Roman"/>
-              </a:rPr>
-              <a:t> </a:t>
-            </a:r>
-            <a:r>
-              <a:rPr sz="2800" spc="-25" dirty="0">
-                <a:solidFill>
-                  <a:srgbClr val="2D5395"/>
-                </a:solidFill>
-                <a:latin typeface="Times New Roman"/>
-                <a:cs typeface="Times New Roman"/>
-              </a:rPr>
-              <a:t>1.5</a:t>
-            </a:r>
-            <a:endParaRPr sz="2800" dirty="0">
-              <a:latin typeface="Times New Roman"/>
-              <a:cs typeface="Times New Roman"/>
-            </a:endParaRPr>
-          </a:p>
-          <a:p>
-            <a:pPr marL="240029" indent="-227329">
-              <a:lnSpc>
-                <a:spcPct val="100000"/>
-              </a:lnSpc>
-              <a:spcBef>
-                <a:spcPts val="2005"/>
-              </a:spcBef>
-              <a:buFont typeface="Arial MT"/>
-              <a:buChar char="•"/>
-              <a:tabLst>
-                <a:tab pos="240029" algn="l"/>
-              </a:tabLst>
-            </a:pPr>
-            <a:r>
-              <a:rPr sz="2800" dirty="0">
-                <a:solidFill>
-                  <a:srgbClr val="2D5395"/>
-                </a:solidFill>
-                <a:latin typeface="Times New Roman"/>
-                <a:cs typeface="Times New Roman"/>
-              </a:rPr>
-              <a:t>Background</a:t>
-            </a:r>
-            <a:r>
-              <a:rPr sz="2800" spc="-90" dirty="0">
-                <a:solidFill>
-                  <a:srgbClr val="2D5395"/>
-                </a:solidFill>
-                <a:latin typeface="Times New Roman"/>
-                <a:cs typeface="Times New Roman"/>
-              </a:rPr>
-              <a:t> </a:t>
-            </a:r>
-            <a:r>
-              <a:rPr sz="2800" dirty="0">
-                <a:solidFill>
-                  <a:srgbClr val="2D5395"/>
-                </a:solidFill>
-                <a:latin typeface="Times New Roman"/>
-                <a:cs typeface="Times New Roman"/>
-              </a:rPr>
-              <a:t>must</a:t>
-            </a:r>
-            <a:r>
-              <a:rPr sz="2800" spc="-95" dirty="0">
-                <a:solidFill>
-                  <a:srgbClr val="2D5395"/>
-                </a:solidFill>
-                <a:latin typeface="Times New Roman"/>
-                <a:cs typeface="Times New Roman"/>
-              </a:rPr>
-              <a:t> </a:t>
-            </a:r>
-            <a:r>
-              <a:rPr sz="2800" dirty="0">
-                <a:solidFill>
-                  <a:srgbClr val="2D5395"/>
-                </a:solidFill>
-                <a:latin typeface="Times New Roman"/>
-                <a:cs typeface="Times New Roman"/>
-              </a:rPr>
-              <a:t>be</a:t>
-            </a:r>
-            <a:r>
-              <a:rPr sz="2800" spc="-100" dirty="0">
-                <a:solidFill>
-                  <a:srgbClr val="2D5395"/>
-                </a:solidFill>
-                <a:latin typeface="Times New Roman"/>
-                <a:cs typeface="Times New Roman"/>
-              </a:rPr>
-              <a:t> </a:t>
-            </a:r>
-            <a:r>
-              <a:rPr sz="2800" spc="-10" dirty="0">
-                <a:solidFill>
-                  <a:srgbClr val="2D5395"/>
-                </a:solidFill>
-                <a:latin typeface="Times New Roman"/>
-                <a:cs typeface="Times New Roman"/>
-              </a:rPr>
-              <a:t>white.</a:t>
-            </a:r>
-            <a:endParaRPr sz="2800" dirty="0">
-              <a:latin typeface="Times New Roman"/>
-              <a:cs typeface="Times New Roman"/>
-            </a:endParaRPr>
+            <a:pPr algn="just">
+              <a:lnSpc>
+                <a:spcPct val="150000"/>
+              </a:lnSpc>
+            </a:pPr>
+            <a:r>
+              <a:rPr sz="1800">
+                <a:latin typeface="Times New Roman"/>
+              </a:rPr>
+              <a:t>ICU mortality ranges 10-29%; early detection of deterioration significantly improves outcomes.</a:t>
+            </a:r>
+          </a:p>
+          <a:p>
+            <a:pPr algn="just">
+              <a:lnSpc>
+                <a:spcPct val="150000"/>
+              </a:lnSpc>
+            </a:pPr>
+            <a:r>
+              <a:rPr sz="1800">
+                <a:latin typeface="Times New Roman"/>
+              </a:rPr>
+              <a:t>Current practice relies on NEWS2, SOFA and APACHE-II with static thresholds and manual calculation.</a:t>
+            </a:r>
+          </a:p>
+          <a:p>
+            <a:pPr algn="just">
+              <a:lnSpc>
+                <a:spcPct val="150000"/>
+              </a:lnSpc>
+            </a:pPr>
+            <a:r>
+              <a:rPr sz="1800">
+                <a:latin typeface="Times New Roman"/>
+              </a:rPr>
+              <a:t>These scores fail to capture temporal trends and have limited sensitivity for early warning.</a:t>
+            </a:r>
+          </a:p>
+          <a:p>
+            <a:pPr algn="just">
+              <a:lnSpc>
+                <a:spcPct val="150000"/>
+              </a:lnSpc>
+            </a:pPr>
+            <a:r>
+              <a:rPr sz="1800">
+                <a:latin typeface="Times New Roman"/>
+              </a:rPr>
+              <a:t>Objective 1-2: build attention-LSTM mortality-risk model with full-stack FastAPI and React system.</a:t>
+            </a:r>
+          </a:p>
+          <a:p>
+            <a:pPr algn="just">
+              <a:lnSpc>
+                <a:spcPct val="150000"/>
+              </a:lnSpc>
+            </a:pPr>
+            <a:r>
+              <a:rPr sz="1800">
+                <a:latin typeface="Times New Roman"/>
+              </a:rPr>
+              <a:t>Objective 3-5: add SHAP + attention explainability, compare against NEWS2, enable scenario simulation.</a:t>
+            </a:r>
           </a:p>
         </p:txBody>
       </p:sp>
@@ -4757,439 +3843,134 @@
             </a:endParaRPr>
           </a:p>
           <a:p>
-            <a:pPr marL="240029" indent="-227329">
-              <a:lnSpc>
-                <a:spcPct val="100000"/>
-              </a:lnSpc>
-              <a:spcBef>
-                <a:spcPts val="3045"/>
-              </a:spcBef>
-              <a:buFont typeface="Arial MT"/>
-              <a:buChar char="•"/>
-              <a:tabLst>
-                <a:tab pos="240029" algn="l"/>
-              </a:tabLst>
-            </a:pPr>
-            <a:r>
-              <a:rPr lang="en-IN" sz="2800" dirty="0">
-                <a:solidFill>
-                  <a:srgbClr val="2D5395"/>
-                </a:solidFill>
-                <a:latin typeface="Times New Roman"/>
-                <a:cs typeface="Times New Roman"/>
-              </a:rPr>
-              <a:t>Table With At Least 10 Papers </a:t>
-            </a:r>
-            <a:r>
-              <a:rPr sz="2800" spc="-10" dirty="0">
-                <a:solidFill>
-                  <a:srgbClr val="2D5395"/>
-                </a:solidFill>
-                <a:latin typeface="Times New Roman"/>
-                <a:cs typeface="Times New Roman"/>
-              </a:rPr>
-              <a:t>.</a:t>
-            </a:r>
-            <a:endParaRPr sz="2800" dirty="0">
-              <a:latin typeface="Times New Roman"/>
-              <a:cs typeface="Times New Roman"/>
-            </a:endParaRPr>
-          </a:p>
-          <a:p>
-            <a:pPr marL="240029" indent="-227329">
-              <a:lnSpc>
-                <a:spcPct val="100000"/>
-              </a:lnSpc>
-              <a:spcBef>
-                <a:spcPts val="2005"/>
-              </a:spcBef>
-              <a:buFont typeface="Arial MT"/>
-              <a:buChar char="•"/>
-              <a:tabLst>
-                <a:tab pos="240029" algn="l"/>
-              </a:tabLst>
-            </a:pPr>
-            <a:r>
-              <a:rPr sz="2800" dirty="0">
-                <a:solidFill>
-                  <a:srgbClr val="2D5395"/>
-                </a:solidFill>
-                <a:latin typeface="Times New Roman"/>
-                <a:cs typeface="Times New Roman"/>
-              </a:rPr>
-              <a:t>Bullets</a:t>
-            </a:r>
-            <a:r>
-              <a:rPr sz="2800" spc="-65" dirty="0">
-                <a:solidFill>
-                  <a:srgbClr val="2D5395"/>
-                </a:solidFill>
-                <a:latin typeface="Times New Roman"/>
-                <a:cs typeface="Times New Roman"/>
-              </a:rPr>
-              <a:t> </a:t>
-            </a:r>
-            <a:r>
-              <a:rPr sz="2800" dirty="0">
-                <a:solidFill>
-                  <a:srgbClr val="2D5395"/>
-                </a:solidFill>
-                <a:latin typeface="Times New Roman"/>
-                <a:cs typeface="Times New Roman"/>
-              </a:rPr>
-              <a:t>should</a:t>
-            </a:r>
-            <a:r>
-              <a:rPr sz="2800" spc="-80" dirty="0">
-                <a:solidFill>
-                  <a:srgbClr val="2D5395"/>
-                </a:solidFill>
-                <a:latin typeface="Times New Roman"/>
-                <a:cs typeface="Times New Roman"/>
-              </a:rPr>
-              <a:t> </a:t>
-            </a:r>
-            <a:r>
-              <a:rPr sz="2800" dirty="0">
-                <a:solidFill>
-                  <a:srgbClr val="2D5395"/>
-                </a:solidFill>
-                <a:latin typeface="Times New Roman"/>
-                <a:cs typeface="Times New Roman"/>
-              </a:rPr>
-              <a:t>be</a:t>
-            </a:r>
-            <a:r>
-              <a:rPr sz="2800" spc="-65" dirty="0">
-                <a:solidFill>
-                  <a:srgbClr val="2D5395"/>
-                </a:solidFill>
-                <a:latin typeface="Times New Roman"/>
-                <a:cs typeface="Times New Roman"/>
-              </a:rPr>
-              <a:t> </a:t>
-            </a:r>
-            <a:r>
-              <a:rPr sz="2800" dirty="0">
-                <a:solidFill>
-                  <a:srgbClr val="2D5395"/>
-                </a:solidFill>
-                <a:latin typeface="Times New Roman"/>
-                <a:cs typeface="Times New Roman"/>
-              </a:rPr>
-              <a:t>same</a:t>
-            </a:r>
-            <a:r>
-              <a:rPr sz="2800" spc="-20" dirty="0">
-                <a:solidFill>
-                  <a:srgbClr val="2D5395"/>
-                </a:solidFill>
-                <a:latin typeface="Times New Roman"/>
-                <a:cs typeface="Times New Roman"/>
-              </a:rPr>
-              <a:t> </a:t>
-            </a:r>
-            <a:r>
-              <a:rPr sz="2800" spc="-10" dirty="0">
-                <a:solidFill>
-                  <a:srgbClr val="2D5395"/>
-                </a:solidFill>
-                <a:latin typeface="Times New Roman"/>
-                <a:cs typeface="Times New Roman"/>
-              </a:rPr>
-              <a:t>throughout.</a:t>
-            </a:r>
-            <a:endParaRPr sz="2800" dirty="0">
-              <a:latin typeface="Times New Roman"/>
-              <a:cs typeface="Times New Roman"/>
-            </a:endParaRPr>
-          </a:p>
-          <a:p>
-            <a:pPr marL="240029" indent="-227329">
-              <a:lnSpc>
-                <a:spcPct val="100000"/>
-              </a:lnSpc>
-              <a:spcBef>
-                <a:spcPts val="2005"/>
-              </a:spcBef>
-              <a:buFont typeface="Arial MT"/>
-              <a:buChar char="•"/>
-              <a:tabLst>
-                <a:tab pos="240029" algn="l"/>
-              </a:tabLst>
-            </a:pPr>
-            <a:r>
-              <a:rPr sz="2800" dirty="0">
-                <a:solidFill>
-                  <a:srgbClr val="2D5395"/>
-                </a:solidFill>
-                <a:latin typeface="Times New Roman"/>
-                <a:cs typeface="Times New Roman"/>
-              </a:rPr>
-              <a:t>Font</a:t>
-            </a:r>
-            <a:r>
-              <a:rPr sz="2800" spc="-114" dirty="0">
-                <a:solidFill>
-                  <a:srgbClr val="2D5395"/>
-                </a:solidFill>
-                <a:latin typeface="Times New Roman"/>
-                <a:cs typeface="Times New Roman"/>
-              </a:rPr>
-              <a:t> </a:t>
-            </a:r>
-            <a:r>
-              <a:rPr sz="2800" dirty="0">
-                <a:solidFill>
-                  <a:srgbClr val="2D5395"/>
-                </a:solidFill>
-                <a:latin typeface="Times New Roman"/>
-                <a:cs typeface="Times New Roman"/>
-              </a:rPr>
-              <a:t>must</a:t>
-            </a:r>
-            <a:r>
-              <a:rPr sz="2800" spc="-75" dirty="0">
-                <a:solidFill>
-                  <a:srgbClr val="2D5395"/>
-                </a:solidFill>
-                <a:latin typeface="Times New Roman"/>
-                <a:cs typeface="Times New Roman"/>
-              </a:rPr>
-              <a:t> </a:t>
-            </a:r>
-            <a:r>
-              <a:rPr sz="2800" dirty="0">
-                <a:solidFill>
-                  <a:srgbClr val="2D5395"/>
-                </a:solidFill>
-                <a:latin typeface="Times New Roman"/>
-                <a:cs typeface="Times New Roman"/>
-              </a:rPr>
-              <a:t>be</a:t>
-            </a:r>
-            <a:r>
-              <a:rPr sz="2800" spc="-150" dirty="0">
-                <a:solidFill>
-                  <a:srgbClr val="2D5395"/>
-                </a:solidFill>
-                <a:latin typeface="Times New Roman"/>
-                <a:cs typeface="Times New Roman"/>
-              </a:rPr>
-              <a:t> </a:t>
-            </a:r>
-            <a:r>
-              <a:rPr sz="2800" dirty="0">
-                <a:solidFill>
-                  <a:srgbClr val="2D5395"/>
-                </a:solidFill>
-                <a:latin typeface="Times New Roman"/>
-                <a:cs typeface="Times New Roman"/>
-              </a:rPr>
-              <a:t>Times</a:t>
-            </a:r>
-            <a:r>
-              <a:rPr sz="2800" spc="-70" dirty="0">
-                <a:solidFill>
-                  <a:srgbClr val="2D5395"/>
-                </a:solidFill>
-                <a:latin typeface="Times New Roman"/>
-                <a:cs typeface="Times New Roman"/>
-              </a:rPr>
-              <a:t> </a:t>
-            </a:r>
-            <a:r>
-              <a:rPr sz="2800" dirty="0">
-                <a:solidFill>
-                  <a:srgbClr val="2D5395"/>
-                </a:solidFill>
-                <a:latin typeface="Times New Roman"/>
-                <a:cs typeface="Times New Roman"/>
-              </a:rPr>
-              <a:t>New</a:t>
-            </a:r>
-            <a:r>
-              <a:rPr sz="2800" spc="-80" dirty="0">
-                <a:solidFill>
-                  <a:srgbClr val="2D5395"/>
-                </a:solidFill>
-                <a:latin typeface="Times New Roman"/>
-                <a:cs typeface="Times New Roman"/>
-              </a:rPr>
-              <a:t> </a:t>
-            </a:r>
-            <a:r>
-              <a:rPr sz="2800" spc="-10" dirty="0">
-                <a:solidFill>
-                  <a:srgbClr val="2D5395"/>
-                </a:solidFill>
-                <a:latin typeface="Times New Roman"/>
-                <a:cs typeface="Times New Roman"/>
-              </a:rPr>
-              <a:t>Roman.</a:t>
-            </a:r>
-            <a:endParaRPr sz="2800" dirty="0">
-              <a:latin typeface="Times New Roman"/>
-              <a:cs typeface="Times New Roman"/>
-            </a:endParaRPr>
-          </a:p>
-          <a:p>
-            <a:pPr marL="240029" indent="-227329">
-              <a:lnSpc>
-                <a:spcPct val="100000"/>
-              </a:lnSpc>
-              <a:spcBef>
-                <a:spcPts val="1995"/>
-              </a:spcBef>
-              <a:buFont typeface="Arial MT"/>
-              <a:buChar char="•"/>
-              <a:tabLst>
-                <a:tab pos="240029" algn="l"/>
-              </a:tabLst>
-            </a:pPr>
-            <a:r>
-              <a:rPr sz="2800" dirty="0">
-                <a:solidFill>
-                  <a:srgbClr val="2D5395"/>
-                </a:solidFill>
-                <a:latin typeface="Times New Roman"/>
-                <a:cs typeface="Times New Roman"/>
-              </a:rPr>
-              <a:t>Line</a:t>
-            </a:r>
-            <a:r>
-              <a:rPr sz="2800" spc="-125" dirty="0">
-                <a:solidFill>
-                  <a:srgbClr val="2D5395"/>
-                </a:solidFill>
-                <a:latin typeface="Times New Roman"/>
-                <a:cs typeface="Times New Roman"/>
-              </a:rPr>
-              <a:t> </a:t>
-            </a:r>
-            <a:r>
-              <a:rPr sz="2800" dirty="0">
-                <a:solidFill>
-                  <a:srgbClr val="2D5395"/>
-                </a:solidFill>
-                <a:latin typeface="Times New Roman"/>
-                <a:cs typeface="Times New Roman"/>
-              </a:rPr>
-              <a:t>spacing</a:t>
-            </a:r>
-            <a:r>
-              <a:rPr sz="2800" spc="-135" dirty="0">
-                <a:solidFill>
-                  <a:srgbClr val="2D5395"/>
-                </a:solidFill>
-                <a:latin typeface="Times New Roman"/>
-                <a:cs typeface="Times New Roman"/>
-              </a:rPr>
-              <a:t> </a:t>
-            </a:r>
-            <a:r>
-              <a:rPr sz="2800" spc="-25" dirty="0">
-                <a:solidFill>
-                  <a:srgbClr val="2D5395"/>
-                </a:solidFill>
-                <a:latin typeface="Times New Roman"/>
-                <a:cs typeface="Times New Roman"/>
-              </a:rPr>
-              <a:t>1.5</a:t>
-            </a:r>
-            <a:endParaRPr sz="2800" dirty="0">
-              <a:latin typeface="Times New Roman"/>
-              <a:cs typeface="Times New Roman"/>
-            </a:endParaRPr>
-          </a:p>
-          <a:p>
-            <a:pPr marL="240029" indent="-227329">
-              <a:lnSpc>
-                <a:spcPct val="100000"/>
-              </a:lnSpc>
-              <a:spcBef>
-                <a:spcPts val="2005"/>
-              </a:spcBef>
-              <a:buFont typeface="Arial MT"/>
-              <a:buChar char="•"/>
-              <a:tabLst>
-                <a:tab pos="240029" algn="l"/>
-              </a:tabLst>
-            </a:pPr>
-            <a:r>
-              <a:rPr sz="2800" dirty="0">
-                <a:solidFill>
-                  <a:srgbClr val="2D5395"/>
-                </a:solidFill>
-                <a:latin typeface="Times New Roman"/>
-                <a:cs typeface="Times New Roman"/>
-              </a:rPr>
-              <a:t>Background</a:t>
-            </a:r>
-            <a:r>
-              <a:rPr sz="2800" spc="-90" dirty="0">
-                <a:solidFill>
-                  <a:srgbClr val="2D5395"/>
-                </a:solidFill>
-                <a:latin typeface="Times New Roman"/>
-                <a:cs typeface="Times New Roman"/>
-              </a:rPr>
-              <a:t> </a:t>
-            </a:r>
-            <a:r>
-              <a:rPr sz="2800" dirty="0">
-                <a:solidFill>
-                  <a:srgbClr val="2D5395"/>
-                </a:solidFill>
-                <a:latin typeface="Times New Roman"/>
-                <a:cs typeface="Times New Roman"/>
-              </a:rPr>
-              <a:t>must</a:t>
-            </a:r>
-            <a:r>
-              <a:rPr sz="2800" spc="-95" dirty="0">
-                <a:solidFill>
-                  <a:srgbClr val="2D5395"/>
-                </a:solidFill>
-                <a:latin typeface="Times New Roman"/>
-                <a:cs typeface="Times New Roman"/>
-              </a:rPr>
-              <a:t> </a:t>
-            </a:r>
-            <a:r>
-              <a:rPr sz="2800" dirty="0">
-                <a:solidFill>
-                  <a:srgbClr val="2D5395"/>
-                </a:solidFill>
-                <a:latin typeface="Times New Roman"/>
-                <a:cs typeface="Times New Roman"/>
-              </a:rPr>
-              <a:t>be</a:t>
-            </a:r>
-            <a:r>
-              <a:rPr sz="2800" spc="-100" dirty="0">
-                <a:solidFill>
-                  <a:srgbClr val="2D5395"/>
-                </a:solidFill>
-                <a:latin typeface="Times New Roman"/>
-                <a:cs typeface="Times New Roman"/>
-              </a:rPr>
-              <a:t> </a:t>
-            </a:r>
-            <a:r>
-              <a:rPr sz="2800" spc="-10" dirty="0">
-                <a:solidFill>
-                  <a:srgbClr val="2D5395"/>
-                </a:solidFill>
-                <a:latin typeface="Times New Roman"/>
-                <a:cs typeface="Times New Roman"/>
-              </a:rPr>
-              <a:t>white.</a:t>
-            </a:r>
-            <a:endParaRPr sz="2800" dirty="0">
-              <a:latin typeface="Times New Roman"/>
-              <a:cs typeface="Times New Roman"/>
-            </a:endParaRPr>
+            <a:pPr algn="just">
+              <a:lnSpc>
+                <a:spcPct val="150000"/>
+              </a:lnSpc>
+            </a:pPr>
+            <a:r>
+              <a:rPr sz="1300">
+                <a:latin typeface="Times New Roman"/>
+              </a:rPr>
+              <a:t>Alshwaheen et al., IEEE Access 2021: LSTM-RNN + GA on MIMIC-III, AUROC 0.933.</a:t>
+            </a:r>
+          </a:p>
+          <a:p>
+            <a:pPr algn="just">
+              <a:lnSpc>
+                <a:spcPct val="150000"/>
+              </a:lnSpc>
+            </a:pPr>
+            <a:r>
+              <a:rPr sz="1300">
+                <a:latin typeface="Times New Roman"/>
+              </a:rPr>
+              <a:t>Choi et al., IEEE JBHI 2020 (DEWS): BiLSTM + attention, AUROC 0.880, beats NEWS2.</a:t>
+            </a:r>
+          </a:p>
+          <a:p>
+            <a:pPr algn="just">
+              <a:lnSpc>
+                <a:spcPct val="150000"/>
+              </a:lnSpc>
+            </a:pPr>
+            <a:r>
+              <a:rPr sz="1300">
+                <a:latin typeface="Times New Roman"/>
+              </a:rPr>
+              <a:t>Li et al., IEEE Access 2025 (ARLF): attention residual LSTM-FCN, +0.073 AUC from attention.</a:t>
+            </a:r>
+          </a:p>
+          <a:p>
+            <a:pPr algn="just">
+              <a:lnSpc>
+                <a:spcPct val="150000"/>
+              </a:lnSpc>
+            </a:pPr>
+            <a:r>
+              <a:rPr sz="1300">
+                <a:latin typeface="Times New Roman"/>
+              </a:rPr>
+              <a:t>Zheng et al., JMIR 2025 (Base, TBAL): time-aware BiLSTM-attention, dynamic AUROC 0.936. Adaptation target.</a:t>
+            </a:r>
+          </a:p>
+          <a:p>
+            <a:pPr algn="just">
+              <a:lnSpc>
+                <a:spcPct val="150000"/>
+              </a:lnSpc>
+            </a:pPr>
+            <a:r>
+              <a:rPr sz="1300">
+                <a:latin typeface="Times New Roman"/>
+              </a:rPr>
+              <a:t>PULSE-ICU, arXiv 2025: Longformer foundation model, mortality AUROC 0.887.</a:t>
+            </a:r>
+          </a:p>
+          <a:p>
+            <a:pPr algn="just">
+              <a:lnSpc>
+                <a:spcPct val="150000"/>
+              </a:lnSpc>
+            </a:pPr>
+            <a:r>
+              <a:rPr sz="1300">
+                <a:latin typeface="Times New Roman"/>
+              </a:rPr>
+              <a:t>GARLIC, arXiv 2026: graph attention on PhysioNet 2012/2019 + MIMIC-III, SOTA AUROC.</a:t>
+            </a:r>
+          </a:p>
+          <a:p>
+            <a:pPr algn="just">
+              <a:lnSpc>
+                <a:spcPct val="150000"/>
+              </a:lnSpc>
+            </a:pPr>
+            <a:r>
+              <a:rPr sz="1300">
+                <a:latin typeface="Times New Roman"/>
+              </a:rPr>
+              <a:t>Yan et al., PeerJ 2026: Informer/LSTM/GRU/Transformer stacking, AUROC 0.95 internal.</a:t>
+            </a:r>
+          </a:p>
+          <a:p>
+            <a:pPr algn="just">
+              <a:lnSpc>
+                <a:spcPct val="150000"/>
+              </a:lnSpc>
+            </a:pPr>
+            <a:r>
+              <a:rPr sz="1300">
+                <a:latin typeface="Times New Roman"/>
+              </a:rPr>
+              <a:t>TA-RNN-Hybrid, arXiv 2026: SNOMED embeddings + dual attention, improved AUC and F2.</a:t>
+            </a:r>
+          </a:p>
+          <a:p>
+            <a:pPr algn="just">
+              <a:lnSpc>
+                <a:spcPct val="150000"/>
+              </a:lnSpc>
+            </a:pPr>
+            <a:r>
+              <a:rPr sz="1300">
+                <a:latin typeface="Times New Roman"/>
+              </a:rPr>
+              <a:t>Scheid et al., Nature Commun. 2025: wearable RNN, AUROC 0.89 with 17h advance warning.</a:t>
+            </a:r>
+          </a:p>
+          <a:p>
+            <a:pPr algn="just">
+              <a:lnSpc>
+                <a:spcPct val="150000"/>
+              </a:lnSpc>
+            </a:pPr>
+            <a:r>
+              <a:rPr sz="1300">
+                <a:latin typeface="Times New Roman"/>
+              </a:rPr>
+              <a:t>Wang et al., npj Digit. Med. 2026 (EAEWS): expert-augmented rules, AUROC over 0.80 with transparency.</a:t>
+            </a:r>
           </a:p>
         </p:txBody>
       </p:sp>
@@ -5592,529 +4373,69 @@
             </a:endParaRPr>
           </a:p>
           <a:p>
-            <a:pPr marL="240029" indent="-227329">
-              <a:lnSpc>
-                <a:spcPct val="100000"/>
-              </a:lnSpc>
-              <a:spcBef>
-                <a:spcPts val="3045"/>
-              </a:spcBef>
-              <a:buFont typeface="Arial MT"/>
-              <a:buChar char="•"/>
-              <a:tabLst>
-                <a:tab pos="240029" algn="l"/>
-              </a:tabLst>
-            </a:pPr>
-            <a:r>
-              <a:rPr sz="2800" dirty="0">
-                <a:solidFill>
-                  <a:srgbClr val="2D5395"/>
-                </a:solidFill>
-                <a:latin typeface="Times New Roman"/>
-                <a:cs typeface="Times New Roman"/>
-              </a:rPr>
-              <a:t>Content</a:t>
-            </a:r>
-            <a:r>
-              <a:rPr sz="2800" spc="-85" dirty="0">
-                <a:solidFill>
-                  <a:srgbClr val="2D5395"/>
-                </a:solidFill>
-                <a:latin typeface="Times New Roman"/>
-                <a:cs typeface="Times New Roman"/>
-              </a:rPr>
-              <a:t> </a:t>
-            </a:r>
-            <a:r>
-              <a:rPr sz="2800" dirty="0">
-                <a:solidFill>
-                  <a:srgbClr val="2D5395"/>
-                </a:solidFill>
-                <a:latin typeface="Times New Roman"/>
-                <a:cs typeface="Times New Roman"/>
-              </a:rPr>
-              <a:t>should</a:t>
-            </a:r>
-            <a:r>
-              <a:rPr sz="2800" spc="-85" dirty="0">
-                <a:solidFill>
-                  <a:srgbClr val="2D5395"/>
-                </a:solidFill>
-                <a:latin typeface="Times New Roman"/>
-                <a:cs typeface="Times New Roman"/>
-              </a:rPr>
-              <a:t> </a:t>
-            </a:r>
-            <a:r>
-              <a:rPr sz="2800" dirty="0">
-                <a:solidFill>
-                  <a:srgbClr val="2D5395"/>
-                </a:solidFill>
-                <a:latin typeface="Times New Roman"/>
-                <a:cs typeface="Times New Roman"/>
-              </a:rPr>
-              <a:t>be</a:t>
-            </a:r>
-            <a:r>
-              <a:rPr sz="2800" spc="-70" dirty="0">
-                <a:solidFill>
-                  <a:srgbClr val="2D5395"/>
-                </a:solidFill>
-                <a:latin typeface="Times New Roman"/>
-                <a:cs typeface="Times New Roman"/>
-              </a:rPr>
-              <a:t> </a:t>
-            </a:r>
-            <a:r>
-              <a:rPr sz="2800" dirty="0">
-                <a:solidFill>
-                  <a:srgbClr val="2D5395"/>
-                </a:solidFill>
-                <a:latin typeface="Times New Roman"/>
-                <a:cs typeface="Times New Roman"/>
-              </a:rPr>
-              <a:t>pointwise</a:t>
-            </a:r>
-            <a:r>
-              <a:rPr sz="2800" spc="-80" dirty="0">
-                <a:solidFill>
-                  <a:srgbClr val="2D5395"/>
-                </a:solidFill>
-                <a:latin typeface="Times New Roman"/>
-                <a:cs typeface="Times New Roman"/>
-              </a:rPr>
-              <a:t> </a:t>
-            </a:r>
-            <a:r>
-              <a:rPr sz="2800" dirty="0">
-                <a:solidFill>
-                  <a:srgbClr val="2D5395"/>
-                </a:solidFill>
-                <a:latin typeface="Times New Roman"/>
-                <a:cs typeface="Times New Roman"/>
-              </a:rPr>
-              <a:t>and</a:t>
-            </a:r>
-            <a:r>
-              <a:rPr sz="2800" spc="-50" dirty="0">
-                <a:solidFill>
-                  <a:srgbClr val="2D5395"/>
-                </a:solidFill>
-                <a:latin typeface="Times New Roman"/>
-                <a:cs typeface="Times New Roman"/>
-              </a:rPr>
-              <a:t> </a:t>
-            </a:r>
-            <a:r>
-              <a:rPr sz="2800" spc="-10" dirty="0">
-                <a:solidFill>
-                  <a:srgbClr val="2D5395"/>
-                </a:solidFill>
-                <a:latin typeface="Times New Roman"/>
-                <a:cs typeface="Times New Roman"/>
-              </a:rPr>
-              <a:t>justified.</a:t>
-            </a:r>
-            <a:endParaRPr sz="2800" dirty="0">
-              <a:latin typeface="Times New Roman"/>
-              <a:cs typeface="Times New Roman"/>
-            </a:endParaRPr>
-          </a:p>
-          <a:p>
-            <a:pPr marL="240029" indent="-227329">
-              <a:lnSpc>
-                <a:spcPct val="100000"/>
-              </a:lnSpc>
-              <a:spcBef>
-                <a:spcPts val="2005"/>
-              </a:spcBef>
-              <a:buFont typeface="Arial MT"/>
-              <a:buChar char="•"/>
-              <a:tabLst>
-                <a:tab pos="240029" algn="l"/>
-              </a:tabLst>
-            </a:pPr>
-            <a:r>
-              <a:rPr sz="2800" dirty="0">
-                <a:solidFill>
-                  <a:srgbClr val="2D5395"/>
-                </a:solidFill>
-                <a:latin typeface="Times New Roman"/>
-                <a:cs typeface="Times New Roman"/>
-              </a:rPr>
-              <a:t>Bullets</a:t>
-            </a:r>
-            <a:r>
-              <a:rPr sz="2800" spc="-65" dirty="0">
-                <a:solidFill>
-                  <a:srgbClr val="2D5395"/>
-                </a:solidFill>
-                <a:latin typeface="Times New Roman"/>
-                <a:cs typeface="Times New Roman"/>
-              </a:rPr>
-              <a:t> </a:t>
-            </a:r>
-            <a:r>
-              <a:rPr sz="2800" dirty="0">
-                <a:solidFill>
-                  <a:srgbClr val="2D5395"/>
-                </a:solidFill>
-                <a:latin typeface="Times New Roman"/>
-                <a:cs typeface="Times New Roman"/>
-              </a:rPr>
-              <a:t>should</a:t>
-            </a:r>
-            <a:r>
-              <a:rPr sz="2800" spc="-80" dirty="0">
-                <a:solidFill>
-                  <a:srgbClr val="2D5395"/>
-                </a:solidFill>
-                <a:latin typeface="Times New Roman"/>
-                <a:cs typeface="Times New Roman"/>
-              </a:rPr>
-              <a:t> </a:t>
-            </a:r>
-            <a:r>
-              <a:rPr sz="2800" dirty="0">
-                <a:solidFill>
-                  <a:srgbClr val="2D5395"/>
-                </a:solidFill>
-                <a:latin typeface="Times New Roman"/>
-                <a:cs typeface="Times New Roman"/>
-              </a:rPr>
-              <a:t>be</a:t>
-            </a:r>
-            <a:r>
-              <a:rPr sz="2800" spc="-65" dirty="0">
-                <a:solidFill>
-                  <a:srgbClr val="2D5395"/>
-                </a:solidFill>
-                <a:latin typeface="Times New Roman"/>
-                <a:cs typeface="Times New Roman"/>
-              </a:rPr>
-              <a:t> </a:t>
-            </a:r>
-            <a:r>
-              <a:rPr sz="2800" dirty="0">
-                <a:solidFill>
-                  <a:srgbClr val="2D5395"/>
-                </a:solidFill>
-                <a:latin typeface="Times New Roman"/>
-                <a:cs typeface="Times New Roman"/>
-              </a:rPr>
-              <a:t>same</a:t>
-            </a:r>
-            <a:r>
-              <a:rPr sz="2800" spc="-20" dirty="0">
-                <a:solidFill>
-                  <a:srgbClr val="2D5395"/>
-                </a:solidFill>
-                <a:latin typeface="Times New Roman"/>
-                <a:cs typeface="Times New Roman"/>
-              </a:rPr>
-              <a:t> </a:t>
-            </a:r>
-            <a:r>
-              <a:rPr sz="2800" spc="-10" dirty="0">
-                <a:solidFill>
-                  <a:srgbClr val="2D5395"/>
-                </a:solidFill>
-                <a:latin typeface="Times New Roman"/>
-                <a:cs typeface="Times New Roman"/>
-              </a:rPr>
-              <a:t>throughout.</a:t>
-            </a:r>
-            <a:endParaRPr sz="2800" dirty="0">
-              <a:latin typeface="Times New Roman"/>
-              <a:cs typeface="Times New Roman"/>
-            </a:endParaRPr>
-          </a:p>
-          <a:p>
-            <a:pPr marL="240029" indent="-227329">
-              <a:lnSpc>
-                <a:spcPct val="100000"/>
-              </a:lnSpc>
-              <a:spcBef>
-                <a:spcPts val="2005"/>
-              </a:spcBef>
-              <a:buFont typeface="Arial MT"/>
-              <a:buChar char="•"/>
-              <a:tabLst>
-                <a:tab pos="240029" algn="l"/>
-              </a:tabLst>
-            </a:pPr>
-            <a:r>
-              <a:rPr sz="2800" dirty="0">
-                <a:solidFill>
-                  <a:srgbClr val="2D5395"/>
-                </a:solidFill>
-                <a:latin typeface="Times New Roman"/>
-                <a:cs typeface="Times New Roman"/>
-              </a:rPr>
-              <a:t>Font</a:t>
-            </a:r>
-            <a:r>
-              <a:rPr sz="2800" spc="-114" dirty="0">
-                <a:solidFill>
-                  <a:srgbClr val="2D5395"/>
-                </a:solidFill>
-                <a:latin typeface="Times New Roman"/>
-                <a:cs typeface="Times New Roman"/>
-              </a:rPr>
-              <a:t> </a:t>
-            </a:r>
-            <a:r>
-              <a:rPr sz="2800" dirty="0">
-                <a:solidFill>
-                  <a:srgbClr val="2D5395"/>
-                </a:solidFill>
-                <a:latin typeface="Times New Roman"/>
-                <a:cs typeface="Times New Roman"/>
-              </a:rPr>
-              <a:t>must</a:t>
-            </a:r>
-            <a:r>
-              <a:rPr sz="2800" spc="-75" dirty="0">
-                <a:solidFill>
-                  <a:srgbClr val="2D5395"/>
-                </a:solidFill>
-                <a:latin typeface="Times New Roman"/>
-                <a:cs typeface="Times New Roman"/>
-              </a:rPr>
-              <a:t> </a:t>
-            </a:r>
-            <a:r>
-              <a:rPr sz="2800" dirty="0">
-                <a:solidFill>
-                  <a:srgbClr val="2D5395"/>
-                </a:solidFill>
-                <a:latin typeface="Times New Roman"/>
-                <a:cs typeface="Times New Roman"/>
-              </a:rPr>
-              <a:t>be</a:t>
-            </a:r>
-            <a:r>
-              <a:rPr sz="2800" spc="-150" dirty="0">
-                <a:solidFill>
-                  <a:srgbClr val="2D5395"/>
-                </a:solidFill>
-                <a:latin typeface="Times New Roman"/>
-                <a:cs typeface="Times New Roman"/>
-              </a:rPr>
-              <a:t> </a:t>
-            </a:r>
-            <a:r>
-              <a:rPr sz="2800" dirty="0">
-                <a:solidFill>
-                  <a:srgbClr val="2D5395"/>
-                </a:solidFill>
-                <a:latin typeface="Times New Roman"/>
-                <a:cs typeface="Times New Roman"/>
-              </a:rPr>
-              <a:t>Times</a:t>
-            </a:r>
-            <a:r>
-              <a:rPr sz="2800" spc="-70" dirty="0">
-                <a:solidFill>
-                  <a:srgbClr val="2D5395"/>
-                </a:solidFill>
-                <a:latin typeface="Times New Roman"/>
-                <a:cs typeface="Times New Roman"/>
-              </a:rPr>
-              <a:t> </a:t>
-            </a:r>
-            <a:r>
-              <a:rPr sz="2800" dirty="0">
-                <a:solidFill>
-                  <a:srgbClr val="2D5395"/>
-                </a:solidFill>
-                <a:latin typeface="Times New Roman"/>
-                <a:cs typeface="Times New Roman"/>
-              </a:rPr>
-              <a:t>New</a:t>
-            </a:r>
-            <a:r>
-              <a:rPr sz="2800" spc="-80" dirty="0">
-                <a:solidFill>
-                  <a:srgbClr val="2D5395"/>
-                </a:solidFill>
-                <a:latin typeface="Times New Roman"/>
-                <a:cs typeface="Times New Roman"/>
-              </a:rPr>
-              <a:t> </a:t>
-            </a:r>
-            <a:r>
-              <a:rPr sz="2800" spc="-10" dirty="0">
-                <a:solidFill>
-                  <a:srgbClr val="2D5395"/>
-                </a:solidFill>
-                <a:latin typeface="Times New Roman"/>
-                <a:cs typeface="Times New Roman"/>
-              </a:rPr>
-              <a:t>Roman.</a:t>
-            </a:r>
-            <a:endParaRPr sz="2800" dirty="0">
-              <a:latin typeface="Times New Roman"/>
-              <a:cs typeface="Times New Roman"/>
-            </a:endParaRPr>
-          </a:p>
-          <a:p>
-            <a:pPr marL="240029" indent="-227329">
-              <a:lnSpc>
-                <a:spcPct val="100000"/>
-              </a:lnSpc>
-              <a:spcBef>
-                <a:spcPts val="1995"/>
-              </a:spcBef>
-              <a:buFont typeface="Arial MT"/>
-              <a:buChar char="•"/>
-              <a:tabLst>
-                <a:tab pos="240029" algn="l"/>
-              </a:tabLst>
-            </a:pPr>
-            <a:r>
-              <a:rPr sz="2800" dirty="0">
-                <a:solidFill>
-                  <a:srgbClr val="2D5395"/>
-                </a:solidFill>
-                <a:latin typeface="Times New Roman"/>
-                <a:cs typeface="Times New Roman"/>
-              </a:rPr>
-              <a:t>Line</a:t>
-            </a:r>
-            <a:r>
-              <a:rPr sz="2800" spc="-125" dirty="0">
-                <a:solidFill>
-                  <a:srgbClr val="2D5395"/>
-                </a:solidFill>
-                <a:latin typeface="Times New Roman"/>
-                <a:cs typeface="Times New Roman"/>
-              </a:rPr>
-              <a:t> </a:t>
-            </a:r>
-            <a:r>
-              <a:rPr sz="2800" dirty="0">
-                <a:solidFill>
-                  <a:srgbClr val="2D5395"/>
-                </a:solidFill>
-                <a:latin typeface="Times New Roman"/>
-                <a:cs typeface="Times New Roman"/>
-              </a:rPr>
-              <a:t>spacing</a:t>
-            </a:r>
-            <a:r>
-              <a:rPr sz="2800" spc="-135" dirty="0">
-                <a:solidFill>
-                  <a:srgbClr val="2D5395"/>
-                </a:solidFill>
-                <a:latin typeface="Times New Roman"/>
-                <a:cs typeface="Times New Roman"/>
-              </a:rPr>
-              <a:t> </a:t>
-            </a:r>
-            <a:r>
-              <a:rPr sz="2800" spc="-25" dirty="0">
-                <a:solidFill>
-                  <a:srgbClr val="2D5395"/>
-                </a:solidFill>
-                <a:latin typeface="Times New Roman"/>
-                <a:cs typeface="Times New Roman"/>
-              </a:rPr>
-              <a:t>1.5</a:t>
-            </a:r>
-            <a:endParaRPr sz="2800" dirty="0">
-              <a:latin typeface="Times New Roman"/>
-              <a:cs typeface="Times New Roman"/>
-            </a:endParaRPr>
-          </a:p>
-          <a:p>
-            <a:pPr marL="240029" indent="-227329">
-              <a:lnSpc>
-                <a:spcPct val="100000"/>
-              </a:lnSpc>
-              <a:spcBef>
-                <a:spcPts val="2005"/>
-              </a:spcBef>
-              <a:buFont typeface="Arial MT"/>
-              <a:buChar char="•"/>
-              <a:tabLst>
-                <a:tab pos="240029" algn="l"/>
-              </a:tabLst>
-            </a:pPr>
-            <a:r>
-              <a:rPr sz="2800" dirty="0">
-                <a:solidFill>
-                  <a:srgbClr val="2D5395"/>
-                </a:solidFill>
-                <a:latin typeface="Times New Roman"/>
-                <a:cs typeface="Times New Roman"/>
-              </a:rPr>
-              <a:t>Background</a:t>
-            </a:r>
-            <a:r>
-              <a:rPr sz="2800" spc="-90" dirty="0">
-                <a:solidFill>
-                  <a:srgbClr val="2D5395"/>
-                </a:solidFill>
-                <a:latin typeface="Times New Roman"/>
-                <a:cs typeface="Times New Roman"/>
-              </a:rPr>
-              <a:t> </a:t>
-            </a:r>
-            <a:r>
-              <a:rPr sz="2800" dirty="0">
-                <a:solidFill>
-                  <a:srgbClr val="2D5395"/>
-                </a:solidFill>
-                <a:latin typeface="Times New Roman"/>
-                <a:cs typeface="Times New Roman"/>
-              </a:rPr>
-              <a:t>must</a:t>
-            </a:r>
-            <a:r>
-              <a:rPr sz="2800" spc="-95" dirty="0">
-                <a:solidFill>
-                  <a:srgbClr val="2D5395"/>
-                </a:solidFill>
-                <a:latin typeface="Times New Roman"/>
-                <a:cs typeface="Times New Roman"/>
-              </a:rPr>
-              <a:t> </a:t>
-            </a:r>
-            <a:r>
-              <a:rPr sz="2800" dirty="0">
-                <a:solidFill>
-                  <a:srgbClr val="2D5395"/>
-                </a:solidFill>
-                <a:latin typeface="Times New Roman"/>
-                <a:cs typeface="Times New Roman"/>
-              </a:rPr>
-              <a:t>be</a:t>
-            </a:r>
-            <a:r>
-              <a:rPr sz="2800" spc="-100" dirty="0">
-                <a:solidFill>
-                  <a:srgbClr val="2D5395"/>
-                </a:solidFill>
-                <a:latin typeface="Times New Roman"/>
-                <a:cs typeface="Times New Roman"/>
-              </a:rPr>
-              <a:t> </a:t>
-            </a:r>
-            <a:r>
-              <a:rPr sz="2800" spc="-10" dirty="0">
-                <a:solidFill>
-                  <a:srgbClr val="2D5395"/>
-                </a:solidFill>
-                <a:latin typeface="Times New Roman"/>
-                <a:cs typeface="Times New Roman"/>
-              </a:rPr>
-              <a:t>white.</a:t>
-            </a:r>
-            <a:endParaRPr sz="2800" dirty="0">
-              <a:latin typeface="Times New Roman"/>
-              <a:cs typeface="Times New Roman"/>
-            </a:endParaRPr>
+            <a:pPr algn="just">
+              <a:lnSpc>
+                <a:spcPct val="150000"/>
+              </a:lnSpc>
+            </a:pPr>
+            <a:r>
+              <a:rPr sz="1800">
+                <a:latin typeface="Times New Roman"/>
+              </a:rPr>
+              <a:t>ICU patients need continuous risk assessment, but bedside scores use single-timepoint thresholds.</a:t>
+            </a:r>
+          </a:p>
+          <a:p>
+            <a:pPr algn="just">
+              <a:lnSpc>
+                <a:spcPct val="150000"/>
+              </a:lnSpc>
+            </a:pPr>
+            <a:r>
+              <a:rPr sz="1800">
+                <a:latin typeface="Times New Roman"/>
+              </a:rPr>
+              <a:t>NEWS2 / SOFA / APACHE-II require manual calculation and ignore vital-sign trajectories.</a:t>
+            </a:r>
+          </a:p>
+          <a:p>
+            <a:pPr algn="just">
+              <a:lnSpc>
+                <a:spcPct val="150000"/>
+              </a:lnSpc>
+            </a:pPr>
+            <a:r>
+              <a:rPr sz="1800">
+                <a:latin typeface="Times New Roman"/>
+              </a:rPr>
+              <a:t>Result: late detection, alarm fatigue and limited sensitivity for early deterioration.</a:t>
+            </a:r>
+          </a:p>
+          <a:p>
+            <a:pPr algn="just">
+              <a:lnSpc>
+                <a:spcPct val="150000"/>
+              </a:lnSpc>
+            </a:pPr>
+            <a:r>
+              <a:rPr sz="1800">
+                <a:latin typeface="Times New Roman"/>
+              </a:rPr>
+              <a:t>Need: automated model that learns temporal patterns from streaming vitals and labs.</a:t>
+            </a:r>
+          </a:p>
+          <a:p>
+            <a:pPr algn="just">
+              <a:lnSpc>
+                <a:spcPct val="150000"/>
+              </a:lnSpc>
+            </a:pPr>
+            <a:r>
+              <a:rPr sz="1800">
+                <a:latin typeface="Times New Roman"/>
+              </a:rPr>
+              <a:t>Need: interpretable output so clinicians see which vitals and timepoints drove the risk.</a:t>
+            </a:r>
           </a:p>
         </p:txBody>
       </p:sp>
@@ -6515,539 +4836,82 @@
             </a:endParaRPr>
           </a:p>
           <a:p>
-            <a:pPr marL="240029" indent="-227329">
-              <a:lnSpc>
-                <a:spcPct val="100000"/>
-              </a:lnSpc>
-              <a:spcBef>
-                <a:spcPts val="3045"/>
-              </a:spcBef>
-              <a:buFont typeface="Arial MT"/>
-              <a:buChar char="•"/>
-              <a:tabLst>
-                <a:tab pos="240029" algn="l"/>
-              </a:tabLst>
-            </a:pPr>
-            <a:r>
-              <a:rPr sz="2800" dirty="0">
-                <a:solidFill>
-                  <a:srgbClr val="2D5395"/>
-                </a:solidFill>
-                <a:latin typeface="Times New Roman"/>
-                <a:cs typeface="Times New Roman"/>
-              </a:rPr>
-              <a:t>Content</a:t>
-            </a:r>
-            <a:r>
-              <a:rPr sz="2800" spc="-85" dirty="0">
-                <a:solidFill>
-                  <a:srgbClr val="2D5395"/>
-                </a:solidFill>
-                <a:latin typeface="Times New Roman"/>
-                <a:cs typeface="Times New Roman"/>
-              </a:rPr>
-              <a:t> </a:t>
-            </a:r>
-            <a:r>
-              <a:rPr sz="2800" dirty="0">
-                <a:solidFill>
-                  <a:srgbClr val="2D5395"/>
-                </a:solidFill>
-                <a:latin typeface="Times New Roman"/>
-                <a:cs typeface="Times New Roman"/>
-              </a:rPr>
-              <a:t>should</a:t>
-            </a:r>
-            <a:r>
-              <a:rPr sz="2800" spc="-85" dirty="0">
-                <a:solidFill>
-                  <a:srgbClr val="2D5395"/>
-                </a:solidFill>
-                <a:latin typeface="Times New Roman"/>
-                <a:cs typeface="Times New Roman"/>
-              </a:rPr>
-              <a:t> </a:t>
-            </a:r>
-            <a:r>
-              <a:rPr sz="2800" dirty="0">
-                <a:solidFill>
-                  <a:srgbClr val="2D5395"/>
-                </a:solidFill>
-                <a:latin typeface="Times New Roman"/>
-                <a:cs typeface="Times New Roman"/>
-              </a:rPr>
-              <a:t>be</a:t>
-            </a:r>
-            <a:r>
-              <a:rPr sz="2800" spc="-70" dirty="0">
-                <a:solidFill>
-                  <a:srgbClr val="2D5395"/>
-                </a:solidFill>
-                <a:latin typeface="Times New Roman"/>
-                <a:cs typeface="Times New Roman"/>
-              </a:rPr>
-              <a:t> </a:t>
-            </a:r>
-            <a:r>
-              <a:rPr sz="2800" dirty="0">
-                <a:solidFill>
-                  <a:srgbClr val="2D5395"/>
-                </a:solidFill>
-                <a:latin typeface="Times New Roman"/>
-                <a:cs typeface="Times New Roman"/>
-              </a:rPr>
-              <a:t>pointwise</a:t>
-            </a:r>
-            <a:r>
-              <a:rPr sz="2800" spc="-80" dirty="0">
-                <a:solidFill>
-                  <a:srgbClr val="2D5395"/>
-                </a:solidFill>
-                <a:latin typeface="Times New Roman"/>
-                <a:cs typeface="Times New Roman"/>
-              </a:rPr>
-              <a:t> </a:t>
-            </a:r>
-            <a:r>
-              <a:rPr sz="2800" dirty="0">
-                <a:solidFill>
-                  <a:srgbClr val="2D5395"/>
-                </a:solidFill>
-                <a:latin typeface="Times New Roman"/>
-                <a:cs typeface="Times New Roman"/>
-              </a:rPr>
-              <a:t>and</a:t>
-            </a:r>
-            <a:r>
-              <a:rPr sz="2800" spc="-50" dirty="0">
-                <a:solidFill>
-                  <a:srgbClr val="2D5395"/>
-                </a:solidFill>
-                <a:latin typeface="Times New Roman"/>
-                <a:cs typeface="Times New Roman"/>
-              </a:rPr>
-              <a:t> </a:t>
-            </a:r>
-            <a:r>
-              <a:rPr sz="2800" spc="-10" dirty="0">
-                <a:solidFill>
-                  <a:srgbClr val="2D5395"/>
-                </a:solidFill>
-                <a:latin typeface="Times New Roman"/>
-                <a:cs typeface="Times New Roman"/>
-              </a:rPr>
-              <a:t>justified</a:t>
-            </a:r>
-            <a:r>
-              <a:rPr lang="en-IN" sz="2800" spc="-10" dirty="0">
-                <a:solidFill>
-                  <a:srgbClr val="2D5395"/>
-                </a:solidFill>
-                <a:latin typeface="Times New Roman"/>
-                <a:cs typeface="Times New Roman"/>
-              </a:rPr>
-              <a:t>/ Block Diagram </a:t>
-            </a:r>
-            <a:endParaRPr sz="2800" dirty="0">
-              <a:latin typeface="Times New Roman"/>
-              <a:cs typeface="Times New Roman"/>
-            </a:endParaRPr>
-          </a:p>
-          <a:p>
-            <a:pPr marL="240029" indent="-227329">
-              <a:lnSpc>
-                <a:spcPct val="100000"/>
-              </a:lnSpc>
-              <a:spcBef>
-                <a:spcPts val="2005"/>
-              </a:spcBef>
-              <a:buFont typeface="Arial MT"/>
-              <a:buChar char="•"/>
-              <a:tabLst>
-                <a:tab pos="240029" algn="l"/>
-              </a:tabLst>
-            </a:pPr>
-            <a:r>
-              <a:rPr sz="2800" dirty="0">
-                <a:solidFill>
-                  <a:srgbClr val="2D5395"/>
-                </a:solidFill>
-                <a:latin typeface="Times New Roman"/>
-                <a:cs typeface="Times New Roman"/>
-              </a:rPr>
-              <a:t>Bullets</a:t>
-            </a:r>
-            <a:r>
-              <a:rPr sz="2800" spc="-65" dirty="0">
-                <a:solidFill>
-                  <a:srgbClr val="2D5395"/>
-                </a:solidFill>
-                <a:latin typeface="Times New Roman"/>
-                <a:cs typeface="Times New Roman"/>
-              </a:rPr>
-              <a:t> </a:t>
-            </a:r>
-            <a:r>
-              <a:rPr sz="2800" dirty="0">
-                <a:solidFill>
-                  <a:srgbClr val="2D5395"/>
-                </a:solidFill>
-                <a:latin typeface="Times New Roman"/>
-                <a:cs typeface="Times New Roman"/>
-              </a:rPr>
-              <a:t>should</a:t>
-            </a:r>
-            <a:r>
-              <a:rPr sz="2800" spc="-80" dirty="0">
-                <a:solidFill>
-                  <a:srgbClr val="2D5395"/>
-                </a:solidFill>
-                <a:latin typeface="Times New Roman"/>
-                <a:cs typeface="Times New Roman"/>
-              </a:rPr>
-              <a:t> </a:t>
-            </a:r>
-            <a:r>
-              <a:rPr sz="2800" dirty="0">
-                <a:solidFill>
-                  <a:srgbClr val="2D5395"/>
-                </a:solidFill>
-                <a:latin typeface="Times New Roman"/>
-                <a:cs typeface="Times New Roman"/>
-              </a:rPr>
-              <a:t>be</a:t>
-            </a:r>
-            <a:r>
-              <a:rPr sz="2800" spc="-65" dirty="0">
-                <a:solidFill>
-                  <a:srgbClr val="2D5395"/>
-                </a:solidFill>
-                <a:latin typeface="Times New Roman"/>
-                <a:cs typeface="Times New Roman"/>
-              </a:rPr>
-              <a:t> </a:t>
-            </a:r>
-            <a:r>
-              <a:rPr sz="2800" dirty="0">
-                <a:solidFill>
-                  <a:srgbClr val="2D5395"/>
-                </a:solidFill>
-                <a:latin typeface="Times New Roman"/>
-                <a:cs typeface="Times New Roman"/>
-              </a:rPr>
-              <a:t>same</a:t>
-            </a:r>
-            <a:r>
-              <a:rPr sz="2800" spc="-20" dirty="0">
-                <a:solidFill>
-                  <a:srgbClr val="2D5395"/>
-                </a:solidFill>
-                <a:latin typeface="Times New Roman"/>
-                <a:cs typeface="Times New Roman"/>
-              </a:rPr>
-              <a:t> </a:t>
-            </a:r>
-            <a:r>
-              <a:rPr sz="2800" spc="-10" dirty="0">
-                <a:solidFill>
-                  <a:srgbClr val="2D5395"/>
-                </a:solidFill>
-                <a:latin typeface="Times New Roman"/>
-                <a:cs typeface="Times New Roman"/>
-              </a:rPr>
-              <a:t>throughout.</a:t>
-            </a:r>
-            <a:endParaRPr sz="2800" dirty="0">
-              <a:latin typeface="Times New Roman"/>
-              <a:cs typeface="Times New Roman"/>
-            </a:endParaRPr>
-          </a:p>
-          <a:p>
-            <a:pPr marL="240029" indent="-227329">
-              <a:lnSpc>
-                <a:spcPct val="100000"/>
-              </a:lnSpc>
-              <a:spcBef>
-                <a:spcPts val="2005"/>
-              </a:spcBef>
-              <a:buFont typeface="Arial MT"/>
-              <a:buChar char="•"/>
-              <a:tabLst>
-                <a:tab pos="240029" algn="l"/>
-              </a:tabLst>
-            </a:pPr>
-            <a:r>
-              <a:rPr sz="2800" dirty="0">
-                <a:solidFill>
-                  <a:srgbClr val="2D5395"/>
-                </a:solidFill>
-                <a:latin typeface="Times New Roman"/>
-                <a:cs typeface="Times New Roman"/>
-              </a:rPr>
-              <a:t>Font</a:t>
-            </a:r>
-            <a:r>
-              <a:rPr sz="2800" spc="-114" dirty="0">
-                <a:solidFill>
-                  <a:srgbClr val="2D5395"/>
-                </a:solidFill>
-                <a:latin typeface="Times New Roman"/>
-                <a:cs typeface="Times New Roman"/>
-              </a:rPr>
-              <a:t> </a:t>
-            </a:r>
-            <a:r>
-              <a:rPr sz="2800" dirty="0">
-                <a:solidFill>
-                  <a:srgbClr val="2D5395"/>
-                </a:solidFill>
-                <a:latin typeface="Times New Roman"/>
-                <a:cs typeface="Times New Roman"/>
-              </a:rPr>
-              <a:t>must</a:t>
-            </a:r>
-            <a:r>
-              <a:rPr sz="2800" spc="-75" dirty="0">
-                <a:solidFill>
-                  <a:srgbClr val="2D5395"/>
-                </a:solidFill>
-                <a:latin typeface="Times New Roman"/>
-                <a:cs typeface="Times New Roman"/>
-              </a:rPr>
-              <a:t> </a:t>
-            </a:r>
-            <a:r>
-              <a:rPr sz="2800" dirty="0">
-                <a:solidFill>
-                  <a:srgbClr val="2D5395"/>
-                </a:solidFill>
-                <a:latin typeface="Times New Roman"/>
-                <a:cs typeface="Times New Roman"/>
-              </a:rPr>
-              <a:t>be</a:t>
-            </a:r>
-            <a:r>
-              <a:rPr sz="2800" spc="-150" dirty="0">
-                <a:solidFill>
-                  <a:srgbClr val="2D5395"/>
-                </a:solidFill>
-                <a:latin typeface="Times New Roman"/>
-                <a:cs typeface="Times New Roman"/>
-              </a:rPr>
-              <a:t> </a:t>
-            </a:r>
-            <a:r>
-              <a:rPr sz="2800" dirty="0">
-                <a:solidFill>
-                  <a:srgbClr val="2D5395"/>
-                </a:solidFill>
-                <a:latin typeface="Times New Roman"/>
-                <a:cs typeface="Times New Roman"/>
-              </a:rPr>
-              <a:t>Times</a:t>
-            </a:r>
-            <a:r>
-              <a:rPr sz="2800" spc="-70" dirty="0">
-                <a:solidFill>
-                  <a:srgbClr val="2D5395"/>
-                </a:solidFill>
-                <a:latin typeface="Times New Roman"/>
-                <a:cs typeface="Times New Roman"/>
-              </a:rPr>
-              <a:t> </a:t>
-            </a:r>
-            <a:r>
-              <a:rPr sz="2800" dirty="0">
-                <a:solidFill>
-                  <a:srgbClr val="2D5395"/>
-                </a:solidFill>
-                <a:latin typeface="Times New Roman"/>
-                <a:cs typeface="Times New Roman"/>
-              </a:rPr>
-              <a:t>New</a:t>
-            </a:r>
-            <a:r>
-              <a:rPr sz="2800" spc="-80" dirty="0">
-                <a:solidFill>
-                  <a:srgbClr val="2D5395"/>
-                </a:solidFill>
-                <a:latin typeface="Times New Roman"/>
-                <a:cs typeface="Times New Roman"/>
-              </a:rPr>
-              <a:t> </a:t>
-            </a:r>
-            <a:r>
-              <a:rPr sz="2800" spc="-10" dirty="0">
-                <a:solidFill>
-                  <a:srgbClr val="2D5395"/>
-                </a:solidFill>
-                <a:latin typeface="Times New Roman"/>
-                <a:cs typeface="Times New Roman"/>
-              </a:rPr>
-              <a:t>Roman.</a:t>
-            </a:r>
-            <a:endParaRPr sz="2800" dirty="0">
-              <a:latin typeface="Times New Roman"/>
-              <a:cs typeface="Times New Roman"/>
-            </a:endParaRPr>
-          </a:p>
-          <a:p>
-            <a:pPr marL="240029" indent="-227329">
-              <a:lnSpc>
-                <a:spcPct val="100000"/>
-              </a:lnSpc>
-              <a:spcBef>
-                <a:spcPts val="1995"/>
-              </a:spcBef>
-              <a:buFont typeface="Arial MT"/>
-              <a:buChar char="•"/>
-              <a:tabLst>
-                <a:tab pos="240029" algn="l"/>
-              </a:tabLst>
-            </a:pPr>
-            <a:r>
-              <a:rPr sz="2800" dirty="0">
-                <a:solidFill>
-                  <a:srgbClr val="2D5395"/>
-                </a:solidFill>
-                <a:latin typeface="Times New Roman"/>
-                <a:cs typeface="Times New Roman"/>
-              </a:rPr>
-              <a:t>Line</a:t>
-            </a:r>
-            <a:r>
-              <a:rPr sz="2800" spc="-125" dirty="0">
-                <a:solidFill>
-                  <a:srgbClr val="2D5395"/>
-                </a:solidFill>
-                <a:latin typeface="Times New Roman"/>
-                <a:cs typeface="Times New Roman"/>
-              </a:rPr>
-              <a:t> </a:t>
-            </a:r>
-            <a:r>
-              <a:rPr sz="2800" dirty="0">
-                <a:solidFill>
-                  <a:srgbClr val="2D5395"/>
-                </a:solidFill>
-                <a:latin typeface="Times New Roman"/>
-                <a:cs typeface="Times New Roman"/>
-              </a:rPr>
-              <a:t>spacing</a:t>
-            </a:r>
-            <a:r>
-              <a:rPr sz="2800" spc="-135" dirty="0">
-                <a:solidFill>
-                  <a:srgbClr val="2D5395"/>
-                </a:solidFill>
-                <a:latin typeface="Times New Roman"/>
-                <a:cs typeface="Times New Roman"/>
-              </a:rPr>
-              <a:t> </a:t>
-            </a:r>
-            <a:r>
-              <a:rPr sz="2800" spc="-25" dirty="0">
-                <a:solidFill>
-                  <a:srgbClr val="2D5395"/>
-                </a:solidFill>
-                <a:latin typeface="Times New Roman"/>
-                <a:cs typeface="Times New Roman"/>
-              </a:rPr>
-              <a:t>1.5</a:t>
-            </a:r>
-            <a:endParaRPr sz="2800" dirty="0">
-              <a:latin typeface="Times New Roman"/>
-              <a:cs typeface="Times New Roman"/>
-            </a:endParaRPr>
-          </a:p>
-          <a:p>
-            <a:pPr marL="240029" indent="-227329">
-              <a:lnSpc>
-                <a:spcPct val="100000"/>
-              </a:lnSpc>
-              <a:spcBef>
-                <a:spcPts val="2005"/>
-              </a:spcBef>
-              <a:buFont typeface="Arial MT"/>
-              <a:buChar char="•"/>
-              <a:tabLst>
-                <a:tab pos="240029" algn="l"/>
-              </a:tabLst>
-            </a:pPr>
-            <a:r>
-              <a:rPr sz="2800" dirty="0">
-                <a:solidFill>
-                  <a:srgbClr val="2D5395"/>
-                </a:solidFill>
-                <a:latin typeface="Times New Roman"/>
-                <a:cs typeface="Times New Roman"/>
-              </a:rPr>
-              <a:t>Background</a:t>
-            </a:r>
-            <a:r>
-              <a:rPr sz="2800" spc="-90" dirty="0">
-                <a:solidFill>
-                  <a:srgbClr val="2D5395"/>
-                </a:solidFill>
-                <a:latin typeface="Times New Roman"/>
-                <a:cs typeface="Times New Roman"/>
-              </a:rPr>
-              <a:t> </a:t>
-            </a:r>
-            <a:r>
-              <a:rPr sz="2800" dirty="0">
-                <a:solidFill>
-                  <a:srgbClr val="2D5395"/>
-                </a:solidFill>
-                <a:latin typeface="Times New Roman"/>
-                <a:cs typeface="Times New Roman"/>
-              </a:rPr>
-              <a:t>must</a:t>
-            </a:r>
-            <a:r>
-              <a:rPr sz="2800" spc="-95" dirty="0">
-                <a:solidFill>
-                  <a:srgbClr val="2D5395"/>
-                </a:solidFill>
-                <a:latin typeface="Times New Roman"/>
-                <a:cs typeface="Times New Roman"/>
-              </a:rPr>
-              <a:t> </a:t>
-            </a:r>
-            <a:r>
-              <a:rPr sz="2800" dirty="0">
-                <a:solidFill>
-                  <a:srgbClr val="2D5395"/>
-                </a:solidFill>
-                <a:latin typeface="Times New Roman"/>
-                <a:cs typeface="Times New Roman"/>
-              </a:rPr>
-              <a:t>be</a:t>
-            </a:r>
-            <a:r>
-              <a:rPr sz="2800" spc="-100" dirty="0">
-                <a:solidFill>
-                  <a:srgbClr val="2D5395"/>
-                </a:solidFill>
-                <a:latin typeface="Times New Roman"/>
-                <a:cs typeface="Times New Roman"/>
-              </a:rPr>
-              <a:t> </a:t>
-            </a:r>
-            <a:r>
-              <a:rPr sz="2800" spc="-10" dirty="0">
-                <a:solidFill>
-                  <a:srgbClr val="2D5395"/>
-                </a:solidFill>
-                <a:latin typeface="Times New Roman"/>
-                <a:cs typeface="Times New Roman"/>
-              </a:rPr>
-              <a:t>white.</a:t>
-            </a:r>
-            <a:endParaRPr sz="2800" dirty="0">
-              <a:latin typeface="Times New Roman"/>
-              <a:cs typeface="Times New Roman"/>
-            </a:endParaRPr>
+            <a:pPr algn="just">
+              <a:lnSpc>
+                <a:spcPct val="150000"/>
+              </a:lnSpc>
+            </a:pPr>
+            <a:r>
+              <a:rPr sz="1600">
+                <a:latin typeface="Times New Roman"/>
+              </a:rPr>
+              <a:t>Dataset: PhysioNet 2012 Challenge, 4,000 ICU stays, 37 variables over 48 hours, mortality labels.</a:t>
+            </a:r>
+          </a:p>
+          <a:p>
+            <a:pPr algn="just">
+              <a:lnSpc>
+                <a:spcPct val="150000"/>
+              </a:lnSpc>
+            </a:pPr>
+            <a:r>
+              <a:rPr sz="1600">
+                <a:latin typeface="Times New Roman"/>
+              </a:rPr>
+              <a:t>Features (12): HR, RespRate, Temp, SysBP, DiasBP, SpO2 (via SaO2) + GCS, BUN, Creatinine, WBC, Platelets, Glucose.</a:t>
+            </a:r>
+          </a:p>
+          <a:p>
+            <a:pPr algn="just">
+              <a:lnSpc>
+                <a:spcPct val="150000"/>
+              </a:lnSpc>
+            </a:pPr>
+            <a:r>
+              <a:rPr sz="1600">
+                <a:latin typeface="Times New Roman"/>
+              </a:rPr>
+              <a:t>Preprocessing: 90-min sliding windows, causal per-window interpolation, train-only z-score, patient-level 80/20 split.</a:t>
+            </a:r>
+          </a:p>
+          <a:p>
+            <a:pPr algn="just">
+              <a:lnSpc>
+                <a:spcPct val="150000"/>
+              </a:lnSpc>
+            </a:pPr>
+            <a:r>
+              <a:rPr sz="1600">
+                <a:latin typeface="Times New Roman"/>
+              </a:rPr>
+              <a:t>Model: 2-layer LSTM-96 with additive temporal attention, BatchNorm, dropout 0.3, weighted BCE, Adam with step decay.</a:t>
+            </a:r>
+          </a:p>
+          <a:p>
+            <a:pPr algn="just">
+              <a:lnSpc>
+                <a:spcPct val="150000"/>
+              </a:lnSpc>
+            </a:pPr>
+            <a:r>
+              <a:rPr sz="1600">
+                <a:latin typeface="Times New Roman"/>
+              </a:rPr>
+              <a:t>Training: full set-a plus 80% set-b, early stopping on val AUC; 3-model logit-averaged ensemble for deployment.</a:t>
+            </a:r>
+          </a:p>
+          <a:p>
+            <a:pPr algn="just">
+              <a:lnSpc>
+                <a:spcPct val="150000"/>
+              </a:lnSpc>
+            </a:pPr>
+            <a:r>
+              <a:rPr sz="1600">
+                <a:latin typeface="Times New Roman"/>
+              </a:rPr>
+              <a:t>System: Vitals to FastAPI /ingest to SQLite to ensemble scorer (0-100) to React dashboard and Discord/Telegram alerts.</a:t>
+            </a:r>
           </a:p>
         </p:txBody>
       </p:sp>

</xml_diff>